<commit_message>
Tighten academic wording and fix Phase 4 border
Avoid causal/over-claims: S1 "may improve compliance and provide
conditions for more adaptive locomotion"; S2 goal "smoother torque
generation and improved robustness" (drop "safe"); S3 "progressive
constraint modulation" instead of "adaptive constraint". Replace the
Phase 4 dashed border with a normal solid light-grey frame.

https://claude.ai/code/session_015i3CJw2uiqwwXT61q7nN5g
</commit_message>
<xml_diff>
--- a/docs/progress-report-v1.pptx
+++ b/docs/progress-report-v1.pptx
@@ -698,7 +698,7 @@
 - Flow: observation -&gt; RL torque policy -&gt; biomechanical layer -&gt; torque -&gt; robot; fatigue state feeds back.
 - Biomechanical model: activation smooths the command, a muscle model prevents abrupt torque, fatigue discourages overusing joints.
 - Growth mechanism: torque limit, reward, and control frequency unlock progressively — like an animal maturing.
-- Net effect: safe torques plus generalization, deployed zero-shot.
+- Net effect: smoother, more robust torques plus generalization, demonstrated zero-shot.
 TRANSITION: 'That's what SATA is — here is how WE plan to study it.'</a:t>
             </a:r>
             <a:endParaRPr lang="en-US" dirty="0"/>
@@ -2182,7 +2182,7 @@
                 <a:ea typeface="Calibri" pitchFamily="34" charset="-122"/>
                 <a:cs typeface="Calibri" pitchFamily="34" charset="-120"/>
               </a:rPr>
-              <a:t>→  Torque-based control may enable more compliant interaction and improve adaptation capability.</a:t>
+              <a:t>→  Torque-based control may improve compliance and provide conditions for more adaptive locomotion.</a:t>
             </a:r>
             <a:endParaRPr lang="en-US" sz="1350" dirty="0"/>
           </a:p>
@@ -4316,7 +4316,7 @@
                 <a:ea typeface="Calibri" pitchFamily="34" charset="-122"/>
                 <a:cs typeface="Calibri" pitchFamily="34" charset="-120"/>
               </a:rPr>
-              <a:t>smooth, safe torques that progressively unlock capability — demonstrated zero-shot deployment (sim-to-real).</a:t>
+              <a:t>smoother torque generation and improved robustness through bio-inspired adaptation.</a:t>
             </a:r>
             <a:endParaRPr lang="en-US" sz="1300" dirty="0"/>
           </a:p>
@@ -4778,7 +4778,7 @@
               <a:buNone/>
             </a:pPr>
             <a:r>
-              <a:rPr lang="en-US" sz="1200" dirty="0">
+              <a:rPr lang="en-US" sz="1150" dirty="0">
                 <a:solidFill>
                   <a:srgbClr val="243230"/>
                 </a:solidFill>
@@ -4788,7 +4788,7 @@
               </a:rPr>
               <a:t>Set up Isaac Gym on a CUDA server (container / venv) and run the official SATA training.</a:t>
             </a:r>
-            <a:endParaRPr lang="en-US" sz="1200" dirty="0"/>
+            <a:endParaRPr lang="en-US" sz="1150" dirty="0"/>
           </a:p>
         </p:txBody>
       </p:sp>
@@ -5118,7 +5118,7 @@
               <a:buNone/>
             </a:pPr>
             <a:r>
-              <a:rPr lang="en-US" sz="1200" dirty="0">
+              <a:rPr lang="en-US" sz="1150" dirty="0">
                 <a:solidFill>
                   <a:srgbClr val="243230"/>
                 </a:solidFill>
@@ -5128,7 +5128,7 @@
               </a:rPr>
               <a:t>Disable fatigue · change torque limit · modify growth schedule · vary terrain.</a:t>
             </a:r>
-            <a:endParaRPr lang="en-US" sz="1200" dirty="0"/>
+            <a:endParaRPr lang="en-US" sz="1150" dirty="0"/>
           </a:p>
         </p:txBody>
       </p:sp>
@@ -5458,7 +5458,7 @@
               <a:buNone/>
             </a:pPr>
             <a:r>
-              <a:rPr lang="en-US" sz="1200" dirty="0">
+              <a:rPr lang="en-US" sz="1150" dirty="0">
                 <a:solidFill>
                   <a:srgbClr val="243230"/>
                 </a:solidFill>
@@ -5468,14 +5468,14 @@
               </a:rPr>
               <a:t>Growth ↔ gain scheduling</a:t>
             </a:r>
-            <a:endParaRPr lang="en-US" sz="1200" dirty="0"/>
-          </a:p>
-          <a:p>
-            <a:pPr indent="0" marL="0">
-              <a:buNone/>
-            </a:pPr>
-            <a:r>
-              <a:rPr lang="en-US" sz="1200" dirty="0">
+            <a:endParaRPr lang="en-US" sz="1150" dirty="0"/>
+          </a:p>
+          <a:p>
+            <a:pPr indent="0" marL="0">
+              <a:buNone/>
+            </a:pPr>
+            <a:r>
+              <a:rPr lang="en-US" sz="1150" dirty="0">
                 <a:solidFill>
                   <a:srgbClr val="243230"/>
                 </a:solidFill>
@@ -5485,14 +5485,14 @@
               </a:rPr>
               <a:t>Fatigue ↔ internal feedback</a:t>
             </a:r>
-            <a:endParaRPr lang="en-US" sz="1200" dirty="0"/>
-          </a:p>
-          <a:p>
-            <a:pPr indent="0" marL="0">
-              <a:buNone/>
-            </a:pPr>
-            <a:r>
-              <a:rPr lang="en-US" sz="1200" dirty="0">
+            <a:endParaRPr lang="en-US" sz="1150" dirty="0"/>
+          </a:p>
+          <a:p>
+            <a:pPr indent="0" marL="0">
+              <a:buNone/>
+            </a:pPr>
+            <a:r>
+              <a:rPr lang="en-US" sz="1150" dirty="0">
                 <a:solidFill>
                   <a:srgbClr val="243230"/>
                 </a:solidFill>
@@ -5500,22 +5500,22 @@
                 <a:ea typeface="Calibri" pitchFamily="34" charset="-122"/>
                 <a:cs typeface="Calibri" pitchFamily="34" charset="-120"/>
               </a:rPr>
-              <a:t>Torque limit ↔ adaptive constraint</a:t>
-            </a:r>
-            <a:endParaRPr lang="en-US" sz="1200" dirty="0"/>
-          </a:p>
-          <a:p>
-            <a:pPr indent="0" marL="0">
-              <a:buNone/>
-            </a:pPr>
-            <a:endParaRPr lang="en-US" sz="1200" dirty="0"/>
-          </a:p>
-          <a:p>
-            <a:pPr indent="0" marL="0">
-              <a:buNone/>
-            </a:pPr>
-            <a:r>
-              <a:rPr lang="en-US" sz="1200" dirty="0">
+              <a:t>Torque limit ↔ progressive constraint modulation</a:t>
+            </a:r>
+            <a:endParaRPr lang="en-US" sz="1150" dirty="0"/>
+          </a:p>
+          <a:p>
+            <a:pPr indent="0" marL="0">
+              <a:buNone/>
+            </a:pPr>
+            <a:endParaRPr lang="en-US" sz="1150" dirty="0"/>
+          </a:p>
+          <a:p>
+            <a:pPr indent="0" marL="0">
+              <a:buNone/>
+            </a:pPr>
+            <a:r>
+              <a:rPr lang="en-US" sz="1150" dirty="0">
                 <a:solidFill>
                   <a:srgbClr val="243230"/>
                 </a:solidFill>
@@ -5525,7 +5525,7 @@
               </a:rPr>
               <a:t>(analogies, not claims)</a:t>
             </a:r>
-            <a:endParaRPr lang="en-US" sz="1200" dirty="0"/>
+            <a:endParaRPr lang="en-US" sz="1150" dirty="0"/>
           </a:p>
         </p:txBody>
       </p:sp>
@@ -5660,9 +5660,9 @@
           </a:solidFill>
           <a:ln w="12700">
             <a:solidFill>
-              <a:srgbClr val="7C8A87"/>
+              <a:srgbClr val="E5DFD4"/>
             </a:solidFill>
-            <a:prstDash val="dash"/>
+            <a:prstDash val="solid"/>
           </a:ln>
           <a:effectLst>
             <a:outerShdw sx="100000" sy="100000" kx="0" ky="0" algn="bl" rotWithShape="0" blurRad="63500" dist="25400" dir="8100000">
@@ -5855,7 +5855,7 @@
               <a:buNone/>
             </a:pPr>
             <a:r>
-              <a:rPr lang="en-US" sz="1200" dirty="0">
+              <a:rPr lang="en-US" sz="1150" dirty="0">
                 <a:solidFill>
                   <a:srgbClr val="243230"/>
                 </a:solidFill>
@@ -5865,14 +5865,14 @@
               </a:rPr>
               <a:t>Preliminary exploration.</a:t>
             </a:r>
-            <a:endParaRPr lang="en-US" sz="1200" dirty="0"/>
-          </a:p>
-          <a:p>
-            <a:pPr indent="0" marL="0">
-              <a:buNone/>
-            </a:pPr>
-            <a:r>
-              <a:rPr lang="en-US" sz="1200" dirty="0">
+            <a:endParaRPr lang="en-US" sz="1150" dirty="0"/>
+          </a:p>
+          <a:p>
+            <a:pPr indent="0" marL="0">
+              <a:buNone/>
+            </a:pPr>
+            <a:r>
+              <a:rPr lang="en-US" sz="1150" dirty="0">
                 <a:solidFill>
                   <a:srgbClr val="243230"/>
                 </a:solidFill>
@@ -5882,14 +5882,14 @@
               </a:rPr>
               <a:t> </a:t>
             </a:r>
-            <a:endParaRPr lang="en-US" sz="1200" dirty="0"/>
-          </a:p>
-          <a:p>
-            <a:pPr indent="0" marL="0">
-              <a:buNone/>
-            </a:pPr>
-            <a:r>
-              <a:rPr lang="en-US" sz="1200" dirty="0">
+            <a:endParaRPr lang="en-US" sz="1150" dirty="0"/>
+          </a:p>
+          <a:p>
+            <a:pPr indent="0" marL="0">
+              <a:buNone/>
+            </a:pPr>
+            <a:r>
+              <a:rPr lang="en-US" sz="1150" dirty="0">
                 <a:solidFill>
                   <a:srgbClr val="243230"/>
                 </a:solidFill>
@@ -5903,7 +5903,7 @@
               <a:buNone/>
             </a:pPr>
             <a:r>
-              <a:rPr lang="en-US" sz="1200" baseline="-40000" dirty="0">
+              <a:rPr lang="en-US" sz="1150" baseline="-40000" dirty="0">
                 <a:solidFill>
                   <a:srgbClr val="243230"/>
                 </a:solidFill>
@@ -5917,7 +5917,7 @@
               <a:buNone/>
             </a:pPr>
             <a:r>
-              <a:rPr lang="en-US" sz="1200" dirty="0">
+              <a:rPr lang="en-US" sz="1150" dirty="0">
                 <a:solidFill>
                   <a:srgbClr val="243230"/>
                 </a:solidFill>
@@ -5931,7 +5931,7 @@
               <a:buNone/>
             </a:pPr>
             <a:r>
-              <a:rPr lang="en-US" sz="1200" baseline="-40000" dirty="0">
+              <a:rPr lang="en-US" sz="1150" baseline="-40000" dirty="0">
                 <a:solidFill>
                   <a:srgbClr val="243230"/>
                 </a:solidFill>
@@ -5945,7 +5945,7 @@
               <a:buNone/>
             </a:pPr>
             <a:r>
-              <a:rPr lang="en-US" sz="1200" dirty="0">
+              <a:rPr lang="en-US" sz="1150" dirty="0">
                 <a:solidFill>
                   <a:srgbClr val="243230"/>
                 </a:solidFill>
@@ -5959,7 +5959,7 @@
               <a:buNone/>
             </a:pPr>
             <a:r>
-              <a:rPr lang="en-US" sz="1200" baseline="-40000" dirty="0">
+              <a:rPr lang="en-US" sz="1150" baseline="-40000" dirty="0">
                 <a:solidFill>
                   <a:srgbClr val="243230"/>
                 </a:solidFill>
@@ -5969,14 +5969,14 @@
               </a:rPr>
               <a:t>comp</a:t>
             </a:r>
-            <a:endParaRPr lang="en-US" sz="1200" dirty="0"/>
-          </a:p>
-          <a:p>
-            <a:pPr indent="0" marL="0">
-              <a:buNone/>
-            </a:pPr>
-            <a:r>
-              <a:rPr lang="en-US" sz="1200" dirty="0">
+            <a:endParaRPr lang="en-US" sz="1150" dirty="0"/>
+          </a:p>
+          <a:p>
+            <a:pPr indent="0" marL="0">
+              <a:buNone/>
+            </a:pPr>
+            <a:r>
+              <a:rPr lang="en-US" sz="1150" dirty="0">
                 <a:solidFill>
                   <a:srgbClr val="243230"/>
                 </a:solidFill>
@@ -5986,14 +5986,14 @@
               </a:rPr>
               <a:t> </a:t>
             </a:r>
-            <a:endParaRPr lang="en-US" sz="1200" dirty="0"/>
-          </a:p>
-          <a:p>
-            <a:pPr indent="0" marL="0">
-              <a:buNone/>
-            </a:pPr>
-            <a:r>
-              <a:rPr lang="en-US" sz="1200" dirty="0">
+            <a:endParaRPr lang="en-US" sz="1150" dirty="0"/>
+          </a:p>
+          <a:p>
+            <a:pPr indent="0" marL="0">
+              <a:buNone/>
+            </a:pPr>
+            <a:r>
+              <a:rPr lang="en-US" sz="1150" dirty="0">
                 <a:solidFill>
                   <a:srgbClr val="243230"/>
                 </a:solidFill>
@@ -6003,7 +6003,7 @@
               </a:rPr>
               <a:t>Only if time &amp; feasibility allow.</a:t>
             </a:r>
-            <a:endParaRPr lang="en-US" sz="1200" dirty="0"/>
+            <a:endParaRPr lang="en-US" sz="1150" dirty="0"/>
           </a:p>
         </p:txBody>
       </p:sp>

</xml_diff>

<commit_message>
Add intuition visuals to slides 1 and 2 (react-icons)
S1: a firm-vs-soft-terrain scene (Go2 icons, force arrow, ✗) so
"position control is rigid" reads in seconds. S2: activation/muscle/
fatigue icons (wave/dumbbell/low-battery) on the biomechanical card and
a Go2 icon in the Robot node. Icons rasterized from react-icons via
sharp; generator now async. Slides 3-4 unchanged.

https://claude.ai/code/session_015i3CJw2uiqwwXT61q7nN5g
</commit_message>
<xml_diff>
--- a/docs/progress-report-v1.pptx
+++ b/docs/progress-report-v1.pptx
@@ -1988,7 +1988,7 @@
         <p:spPr>
           <a:xfrm>
             <a:off x="502920" y="1325880"/>
-            <a:ext cx="4983480" cy="1874520"/>
+            <a:ext cx="4983480" cy="1371600"/>
           </a:xfrm>
           <a:prstGeom prst="rect">
             <a:avLst/>
@@ -2020,7 +2020,7 @@
         <p:spPr>
           <a:xfrm>
             <a:off x="502920" y="1325880"/>
-            <a:ext cx="91440" cy="1874520"/>
+            <a:ext cx="91440" cy="1371600"/>
           </a:xfrm>
           <a:prstGeom prst="rect">
             <a:avLst/>
@@ -2039,8 +2039,8 @@
         </p:nvSpPr>
         <p:spPr>
           <a:xfrm>
-            <a:off x="731520" y="1463040"/>
-            <a:ext cx="4572000" cy="320040"/>
+            <a:off x="731520" y="1444752"/>
+            <a:ext cx="4572000" cy="292608"/>
           </a:xfrm>
           <a:prstGeom prst="rect">
             <a:avLst/>
@@ -2078,8 +2078,8 @@
         </p:nvSpPr>
         <p:spPr>
           <a:xfrm>
-            <a:off x="731520" y="1810512"/>
-            <a:ext cx="4572000" cy="1280160"/>
+            <a:off x="731520" y="1755648"/>
+            <a:ext cx="4572000" cy="868680"/>
           </a:xfrm>
           <a:prstGeom prst="rect">
             <a:avLst/>
@@ -2095,7 +2095,7 @@
               <a:buNone/>
             </a:pPr>
             <a:r>
-              <a:rPr lang="en-US" sz="1500" dirty="0">
+              <a:rPr lang="en-US" sz="1400" dirty="0">
                 <a:solidFill>
                   <a:srgbClr val="243230"/>
                 </a:solidFill>
@@ -2103,9 +2103,9 @@
                 <a:ea typeface="Calibri" pitchFamily="34" charset="-122"/>
                 <a:cs typeface="Calibri" pitchFamily="34" charset="-120"/>
               </a:rPr>
-              <a:t>Position-based locomotion is accurate under known conditions but rigid — it struggles with compliance, disturbance handling, unknown terrain, and the sim-to-real gap.</a:t>
-            </a:r>
-            <a:endParaRPr lang="en-US" sz="1500" dirty="0"/>
+              <a:t>Position-based locomotion is accurate under known conditions but rigid — it struggles with compliance, disturbances, unknown terrain, and the sim-to-real gap.</a:t>
+            </a:r>
+            <a:endParaRPr lang="en-US" sz="1400" dirty="0"/>
           </a:p>
         </p:txBody>
       </p:sp>
@@ -2117,28 +2117,387 @@
         </p:nvSpPr>
         <p:spPr>
           <a:xfrm>
-            <a:off x="502920" y="3346704"/>
-            <a:ext cx="4983480" cy="868680"/>
-          </a:xfrm>
-          <a:prstGeom prst="rect">
-            <a:avLst/>
-          </a:prstGeom>
-          <a:solidFill>
-            <a:srgbClr val="DCEDEA"/>
-          </a:solidFill>
-          <a:ln/>
-        </p:spPr>
-      </p:sp>
-      <p:sp>
-        <p:nvSpPr>
-          <p:cNvPr id="11" name="Shape 9"/>
-          <p:cNvSpPr/>
-          <p:nvPr/>
-        </p:nvSpPr>
-        <p:spPr>
-          <a:xfrm>
-            <a:off x="502920" y="3346704"/>
-            <a:ext cx="91440" cy="868680"/>
+            <a:off x="502920" y="2788920"/>
+            <a:ext cx="4983480" cy="1188720"/>
+          </a:xfrm>
+          <a:prstGeom prst="roundRect">
+            <a:avLst>
+              <a:gd name="adj" fmla="val 4615"/>
+            </a:avLst>
+          </a:prstGeom>
+          <a:solidFill>
+            <a:srgbClr val="EFEBE3"/>
+          </a:solidFill>
+          <a:ln w="12700">
+            <a:solidFill>
+              <a:srgbClr val="E5DFD4"/>
+            </a:solidFill>
+            <a:prstDash val="solid"/>
+          </a:ln>
+        </p:spPr>
+      </p:sp>
+      <p:sp>
+        <p:nvSpPr>
+          <p:cNvPr id="11" name="Text 9"/>
+          <p:cNvSpPr/>
+          <p:nvPr/>
+        </p:nvSpPr>
+        <p:spPr>
+          <a:xfrm>
+            <a:off x="658368" y="2834640"/>
+            <a:ext cx="4663440" cy="256032"/>
+          </a:xfrm>
+          <a:prstGeom prst="rect">
+            <a:avLst/>
+          </a:prstGeom>
+          <a:noFill/>
+          <a:ln/>
+        </p:spPr>
+        <p:txBody>
+          <a:bodyPr wrap="square" lIns="0" tIns="0" rIns="0" bIns="0" rtlCol="0" anchor="ctr"/>
+          <a:lstStyle/>
+          <a:p>
+            <a:pPr indent="0" marL="0">
+              <a:buNone/>
+            </a:pPr>
+            <a:r>
+              <a:rPr lang="en-US" sz="1000" b="1" spc="50" kern="0" dirty="0">
+                <a:solidFill>
+                  <a:srgbClr val="B0573F"/>
+                </a:solidFill>
+                <a:latin typeface="Calibri" pitchFamily="34" charset="0"/>
+                <a:ea typeface="Calibri" pitchFamily="34" charset="-122"/>
+                <a:cs typeface="Calibri" pitchFamily="34" charset="-120"/>
+              </a:rPr>
+              <a:t>RIGID CONTROL ON UNKNOWN TERRAIN</a:t>
+            </a:r>
+            <a:endParaRPr lang="en-US" sz="1000" dirty="0"/>
+          </a:p>
+        </p:txBody>
+      </p:sp>
+      <p:sp>
+        <p:nvSpPr>
+          <p:cNvPr id="12" name="Shape 10"/>
+          <p:cNvSpPr/>
+          <p:nvPr/>
+        </p:nvSpPr>
+        <p:spPr>
+          <a:xfrm>
+            <a:off x="777240" y="3675888"/>
+            <a:ext cx="1325880" cy="0"/>
+          </a:xfrm>
+          <a:prstGeom prst="line">
+            <a:avLst/>
+          </a:prstGeom>
+          <a:noFill/>
+          <a:ln w="38100">
+            <a:solidFill>
+              <a:srgbClr val="9A8C7A"/>
+            </a:solidFill>
+            <a:prstDash val="solid"/>
+          </a:ln>
+        </p:spPr>
+      </p:sp>
+      <p:pic>
+        <p:nvPicPr>
+          <p:cNvPr id="13" name="Image 0" descr="preencoded.png">    </p:cNvPr>
+          <p:cNvPicPr>
+            <a:picLocks noChangeAspect="1"/>
+          </p:cNvPicPr>
+          <p:nvPr/>
+        </p:nvPicPr>
+        <p:blipFill>
+          <a:blip r:embed="rId1"/>
+          <a:stretch>
+            <a:fillRect/>
+          </a:stretch>
+        </p:blipFill>
+        <p:spPr>
+          <a:xfrm>
+            <a:off x="1078992" y="3127248"/>
+            <a:ext cx="512064" cy="512064"/>
+          </a:xfrm>
+          <a:prstGeom prst="rect">
+            <a:avLst/>
+          </a:prstGeom>
+        </p:spPr>
+      </p:pic>
+      <p:sp>
+        <p:nvSpPr>
+          <p:cNvPr id="14" name="Text 11"/>
+          <p:cNvSpPr/>
+          <p:nvPr/>
+        </p:nvSpPr>
+        <p:spPr>
+          <a:xfrm>
+            <a:off x="685800" y="3703320"/>
+            <a:ext cx="1463040" cy="237744"/>
+          </a:xfrm>
+          <a:prstGeom prst="rect">
+            <a:avLst/>
+          </a:prstGeom>
+          <a:noFill/>
+          <a:ln/>
+        </p:spPr>
+        <p:txBody>
+          <a:bodyPr wrap="square" lIns="0" tIns="0" rIns="0" bIns="0" rtlCol="0" anchor="ctr"/>
+          <a:lstStyle/>
+          <a:p>
+            <a:pPr algn="ctr" indent="0" marL="0">
+              <a:buNone/>
+            </a:pPr>
+            <a:r>
+              <a:rPr lang="en-US" sz="950" dirty="0">
+                <a:solidFill>
+                  <a:srgbClr val="7C8A87"/>
+                </a:solidFill>
+                <a:latin typeface="Calibri" pitchFamily="34" charset="0"/>
+                <a:ea typeface="Calibri" pitchFamily="34" charset="-122"/>
+                <a:cs typeface="Calibri" pitchFamily="34" charset="-120"/>
+              </a:rPr>
+              <a:t>firm · known</a:t>
+            </a:r>
+            <a:endParaRPr lang="en-US" sz="950" dirty="0"/>
+          </a:p>
+        </p:txBody>
+      </p:sp>
+      <p:pic>
+        <p:nvPicPr>
+          <p:cNvPr id="15" name="Image 1" descr="preencoded.png">    </p:cNvPr>
+          <p:cNvPicPr>
+            <a:picLocks noChangeAspect="1"/>
+          </p:cNvPicPr>
+          <p:nvPr/>
+        </p:nvPicPr>
+        <p:blipFill>
+          <a:blip r:embed="rId2"/>
+          <a:stretch>
+            <a:fillRect/>
+          </a:stretch>
+        </p:blipFill>
+        <p:spPr>
+          <a:xfrm>
+            <a:off x="2286000" y="3310128"/>
+            <a:ext cx="457200" cy="329184"/>
+          </a:xfrm>
+          <a:prstGeom prst="rect">
+            <a:avLst/>
+          </a:prstGeom>
+        </p:spPr>
+      </p:pic>
+      <p:sp>
+        <p:nvSpPr>
+          <p:cNvPr id="16" name="Shape 12"/>
+          <p:cNvSpPr/>
+          <p:nvPr/>
+        </p:nvSpPr>
+        <p:spPr>
+          <a:xfrm>
+            <a:off x="3063240" y="3675888"/>
+            <a:ext cx="777240" cy="0"/>
+          </a:xfrm>
+          <a:prstGeom prst="line">
+            <a:avLst/>
+          </a:prstGeom>
+          <a:noFill/>
+          <a:ln w="38100">
+            <a:solidFill>
+              <a:srgbClr val="B0573F"/>
+            </a:solidFill>
+            <a:prstDash val="solid"/>
+          </a:ln>
+        </p:spPr>
+      </p:sp>
+      <p:sp>
+        <p:nvSpPr>
+          <p:cNvPr id="17" name="Shape 13"/>
+          <p:cNvSpPr/>
+          <p:nvPr/>
+        </p:nvSpPr>
+        <p:spPr>
+          <a:xfrm>
+            <a:off x="3840480" y="3675888"/>
+            <a:ext cx="292608" cy="237744"/>
+          </a:xfrm>
+          <a:prstGeom prst="line">
+            <a:avLst/>
+          </a:prstGeom>
+          <a:noFill/>
+          <a:ln w="38100">
+            <a:solidFill>
+              <a:srgbClr val="B0573F"/>
+            </a:solidFill>
+            <a:prstDash val="solid"/>
+          </a:ln>
+        </p:spPr>
+      </p:sp>
+      <p:sp>
+        <p:nvSpPr>
+          <p:cNvPr id="18" name="Shape 14"/>
+          <p:cNvSpPr/>
+          <p:nvPr/>
+        </p:nvSpPr>
+        <p:spPr>
+          <a:xfrm>
+            <a:off x="4133088" y="3913632"/>
+            <a:ext cx="274320" cy="-237744"/>
+          </a:xfrm>
+          <a:prstGeom prst="line">
+            <a:avLst/>
+          </a:prstGeom>
+          <a:noFill/>
+          <a:ln w="38100">
+            <a:solidFill>
+              <a:srgbClr val="B0573F"/>
+            </a:solidFill>
+            <a:prstDash val="solid"/>
+          </a:ln>
+        </p:spPr>
+      </p:sp>
+      <p:sp>
+        <p:nvSpPr>
+          <p:cNvPr id="19" name="Shape 15"/>
+          <p:cNvSpPr/>
+          <p:nvPr/>
+        </p:nvSpPr>
+        <p:spPr>
+          <a:xfrm>
+            <a:off x="4407408" y="3675888"/>
+            <a:ext cx="822960" cy="0"/>
+          </a:xfrm>
+          <a:prstGeom prst="line">
+            <a:avLst/>
+          </a:prstGeom>
+          <a:noFill/>
+          <a:ln w="38100">
+            <a:solidFill>
+              <a:srgbClr val="B0573F"/>
+            </a:solidFill>
+            <a:prstDash val="solid"/>
+          </a:ln>
+        </p:spPr>
+      </p:sp>
+      <p:pic>
+        <p:nvPicPr>
+          <p:cNvPr id="20" name="Image 2" descr="preencoded.png">    </p:cNvPr>
+          <p:cNvPicPr>
+            <a:picLocks noChangeAspect="1"/>
+          </p:cNvPicPr>
+          <p:nvPr/>
+        </p:nvPicPr>
+        <p:blipFill>
+          <a:blip r:embed="rId3"/>
+          <a:stretch>
+            <a:fillRect/>
+          </a:stretch>
+        </p:blipFill>
+        <p:spPr>
+          <a:xfrm>
+            <a:off x="3611880" y="3127248"/>
+            <a:ext cx="512064" cy="512064"/>
+          </a:xfrm>
+          <a:prstGeom prst="rect">
+            <a:avLst/>
+          </a:prstGeom>
+        </p:spPr>
+      </p:pic>
+      <p:pic>
+        <p:nvPicPr>
+          <p:cNvPr id="21" name="Image 3" descr="preencoded.png">    </p:cNvPr>
+          <p:cNvPicPr>
+            <a:picLocks noChangeAspect="1"/>
+          </p:cNvPicPr>
+          <p:nvPr/>
+        </p:nvPicPr>
+        <p:blipFill>
+          <a:blip r:embed="rId4"/>
+          <a:stretch>
+            <a:fillRect/>
+          </a:stretch>
+        </p:blipFill>
+        <p:spPr>
+          <a:xfrm>
+            <a:off x="4160520" y="3054096"/>
+            <a:ext cx="274320" cy="384048"/>
+          </a:xfrm>
+          <a:prstGeom prst="rect">
+            <a:avLst/>
+          </a:prstGeom>
+        </p:spPr>
+      </p:pic>
+      <p:pic>
+        <p:nvPicPr>
+          <p:cNvPr id="22" name="Image 4" descr="preencoded.png">    </p:cNvPr>
+          <p:cNvPicPr>
+            <a:picLocks noChangeAspect="1"/>
+          </p:cNvPicPr>
+          <p:nvPr/>
+        </p:nvPicPr>
+        <p:blipFill>
+          <a:blip r:embed="rId5"/>
+          <a:stretch>
+            <a:fillRect/>
+          </a:stretch>
+        </p:blipFill>
+        <p:spPr>
+          <a:xfrm>
+            <a:off x="4956048" y="3127248"/>
+            <a:ext cx="237744" cy="237744"/>
+          </a:xfrm>
+          <a:prstGeom prst="rect">
+            <a:avLst/>
+          </a:prstGeom>
+        </p:spPr>
+      </p:pic>
+      <p:sp>
+        <p:nvSpPr>
+          <p:cNvPr id="23" name="Text 16"/>
+          <p:cNvSpPr/>
+          <p:nvPr/>
+        </p:nvSpPr>
+        <p:spPr>
+          <a:xfrm>
+            <a:off x="3063240" y="3703320"/>
+            <a:ext cx="2194560" cy="237744"/>
+          </a:xfrm>
+          <a:prstGeom prst="rect">
+            <a:avLst/>
+          </a:prstGeom>
+          <a:noFill/>
+          <a:ln/>
+        </p:spPr>
+        <p:txBody>
+          <a:bodyPr wrap="square" lIns="0" tIns="0" rIns="0" bIns="0" rtlCol="0" anchor="ctr"/>
+          <a:lstStyle/>
+          <a:p>
+            <a:pPr algn="ctr" indent="0" marL="0">
+              <a:buNone/>
+            </a:pPr>
+            <a:r>
+              <a:rPr lang="en-US" sz="950" dirty="0">
+                <a:solidFill>
+                  <a:srgbClr val="B0573F"/>
+                </a:solidFill>
+                <a:latin typeface="Calibri" pitchFamily="34" charset="0"/>
+                <a:ea typeface="Calibri" pitchFamily="34" charset="-122"/>
+                <a:cs typeface="Calibri" pitchFamily="34" charset="-120"/>
+              </a:rPr>
+              <a:t>soft · unknown</a:t>
+            </a:r>
+            <a:endParaRPr lang="en-US" sz="950" dirty="0"/>
+          </a:p>
+        </p:txBody>
+      </p:sp>
+      <p:sp>
+        <p:nvSpPr>
+          <p:cNvPr id="24" name="Shape 17"/>
+          <p:cNvSpPr/>
+          <p:nvPr/>
+        </p:nvSpPr>
+        <p:spPr>
+          <a:xfrm>
+            <a:off x="502920" y="4133088"/>
+            <a:ext cx="73152" cy="566928"/>
           </a:xfrm>
           <a:prstGeom prst="rect">
             <a:avLst/>
@@ -2151,14 +2510,14 @@
       </p:sp>
       <p:sp>
         <p:nvSpPr>
-          <p:cNvPr id="12" name="Text 10"/>
-          <p:cNvSpPr/>
-          <p:nvPr/>
-        </p:nvSpPr>
-        <p:spPr>
-          <a:xfrm>
-            <a:off x="731520" y="3346704"/>
-            <a:ext cx="4617720" cy="868680"/>
+          <p:cNvPr id="25" name="Text 18"/>
+          <p:cNvSpPr/>
+          <p:nvPr/>
+        </p:nvSpPr>
+        <p:spPr>
+          <a:xfrm>
+            <a:off x="685800" y="4114800"/>
+            <a:ext cx="4800600" cy="603504"/>
           </a:xfrm>
           <a:prstGeom prst="rect">
             <a:avLst/>
@@ -2174,7 +2533,7 @@
               <a:buNone/>
             </a:pPr>
             <a:r>
-              <a:rPr lang="en-US" sz="1350" b="1" dirty="0">
+              <a:rPr lang="en-US" sz="1250" b="1" dirty="0">
                 <a:solidFill>
                   <a:srgbClr val="0E7C7B"/>
                 </a:solidFill>
@@ -2182,15 +2541,15 @@
                 <a:ea typeface="Calibri" pitchFamily="34" charset="-122"/>
                 <a:cs typeface="Calibri" pitchFamily="34" charset="-120"/>
               </a:rPr>
-              <a:t>→  Torque-based control may improve compliance and provide conditions for more adaptive locomotion.</a:t>
-            </a:r>
-            <a:endParaRPr lang="en-US" sz="1350" dirty="0"/>
-          </a:p>
-        </p:txBody>
-      </p:sp>
-      <p:sp>
-        <p:nvSpPr>
-          <p:cNvPr id="13" name="Shape 11"/>
+              <a:t>→  Torque control may improve compliance, providing conditions for more adaptive locomotion.</a:t>
+            </a:r>
+            <a:endParaRPr lang="en-US" sz="1250" dirty="0"/>
+          </a:p>
+        </p:txBody>
+      </p:sp>
+      <p:sp>
+        <p:nvSpPr>
+          <p:cNvPr id="26" name="Shape 19"/>
           <p:cNvSpPr/>
           <p:nvPr/>
         </p:nvSpPr>
@@ -2210,7 +2569,7 @@
       </p:sp>
       <p:sp>
         <p:nvSpPr>
-          <p:cNvPr id="14" name="Text 12"/>
+          <p:cNvPr id="27" name="Text 20"/>
           <p:cNvSpPr/>
           <p:nvPr/>
         </p:nvSpPr>
@@ -2249,7 +2608,7 @@
       </p:sp>
       <p:sp>
         <p:nvSpPr>
-          <p:cNvPr id="15" name="Shape 13"/>
+          <p:cNvPr id="28" name="Shape 21"/>
           <p:cNvSpPr/>
           <p:nvPr/>
         </p:nvSpPr>
@@ -2269,7 +2628,7 @@
       </p:sp>
       <p:sp>
         <p:nvSpPr>
-          <p:cNvPr id="16" name="Text 14"/>
+          <p:cNvPr id="29" name="Text 22"/>
           <p:cNvSpPr/>
           <p:nvPr/>
         </p:nvSpPr>
@@ -2308,7 +2667,7 @@
       </p:sp>
       <p:sp>
         <p:nvSpPr>
-          <p:cNvPr id="17" name="Shape 15"/>
+          <p:cNvPr id="30" name="Shape 23"/>
           <p:cNvSpPr/>
           <p:nvPr/>
         </p:nvSpPr>
@@ -2333,7 +2692,7 @@
       </p:sp>
       <p:sp>
         <p:nvSpPr>
-          <p:cNvPr id="18" name="Text 16"/>
+          <p:cNvPr id="31" name="Text 24"/>
           <p:cNvSpPr/>
           <p:nvPr/>
         </p:nvSpPr>
@@ -2372,7 +2731,7 @@
       </p:sp>
       <p:sp>
         <p:nvSpPr>
-          <p:cNvPr id="19" name="Shape 17"/>
+          <p:cNvPr id="32" name="Shape 25"/>
           <p:cNvSpPr/>
           <p:nvPr/>
         </p:nvSpPr>
@@ -2397,7 +2756,7 @@
       </p:sp>
       <p:sp>
         <p:nvSpPr>
-          <p:cNvPr id="20" name="Text 18"/>
+          <p:cNvPr id="33" name="Text 26"/>
           <p:cNvSpPr/>
           <p:nvPr/>
         </p:nvSpPr>
@@ -2436,7 +2795,7 @@
       </p:sp>
       <p:sp>
         <p:nvSpPr>
-          <p:cNvPr id="21" name="Text 19"/>
+          <p:cNvPr id="34" name="Text 27"/>
           <p:cNvSpPr/>
           <p:nvPr/>
         </p:nvSpPr>
@@ -2472,7 +2831,7 @@
       </p:sp>
       <p:sp>
         <p:nvSpPr>
-          <p:cNvPr id="22" name="Text 20"/>
+          <p:cNvPr id="35" name="Text 28"/>
           <p:cNvSpPr/>
           <p:nvPr/>
         </p:nvSpPr>
@@ -2508,7 +2867,7 @@
       </p:sp>
       <p:sp>
         <p:nvSpPr>
-          <p:cNvPr id="23" name="Shape 21"/>
+          <p:cNvPr id="36" name="Shape 29"/>
           <p:cNvSpPr/>
           <p:nvPr/>
         </p:nvSpPr>
@@ -2533,7 +2892,7 @@
       </p:sp>
       <p:sp>
         <p:nvSpPr>
-          <p:cNvPr id="24" name="Text 22"/>
+          <p:cNvPr id="37" name="Text 30"/>
           <p:cNvSpPr/>
           <p:nvPr/>
         </p:nvSpPr>
@@ -2572,7 +2931,7 @@
       </p:sp>
       <p:sp>
         <p:nvSpPr>
-          <p:cNvPr id="25" name="Shape 23"/>
+          <p:cNvPr id="38" name="Shape 31"/>
           <p:cNvSpPr/>
           <p:nvPr/>
         </p:nvSpPr>
@@ -2597,7 +2956,7 @@
       </p:sp>
       <p:sp>
         <p:nvSpPr>
-          <p:cNvPr id="26" name="Text 24"/>
+          <p:cNvPr id="39" name="Text 32"/>
           <p:cNvSpPr/>
           <p:nvPr/>
         </p:nvSpPr>
@@ -2636,7 +2995,7 @@
       </p:sp>
       <p:sp>
         <p:nvSpPr>
-          <p:cNvPr id="27" name="Text 25"/>
+          <p:cNvPr id="40" name="Text 33"/>
           <p:cNvSpPr/>
           <p:nvPr/>
         </p:nvSpPr>
@@ -2672,7 +3031,7 @@
       </p:sp>
       <p:sp>
         <p:nvSpPr>
-          <p:cNvPr id="28" name="Text 26"/>
+          <p:cNvPr id="41" name="Text 34"/>
           <p:cNvSpPr/>
           <p:nvPr/>
         </p:nvSpPr>
@@ -2708,7 +3067,7 @@
       </p:sp>
       <p:sp>
         <p:nvSpPr>
-          <p:cNvPr id="29" name="Shape 27"/>
+          <p:cNvPr id="42" name="Shape 35"/>
           <p:cNvSpPr/>
           <p:nvPr/>
         </p:nvSpPr>
@@ -2733,7 +3092,7 @@
       </p:sp>
       <p:sp>
         <p:nvSpPr>
-          <p:cNvPr id="30" name="Text 28"/>
+          <p:cNvPr id="43" name="Text 36"/>
           <p:cNvSpPr/>
           <p:nvPr/>
         </p:nvSpPr>
@@ -2772,7 +3131,7 @@
       </p:sp>
       <p:sp>
         <p:nvSpPr>
-          <p:cNvPr id="31" name="Shape 29"/>
+          <p:cNvPr id="44" name="Shape 37"/>
           <p:cNvSpPr/>
           <p:nvPr/>
         </p:nvSpPr>
@@ -2797,7 +3156,7 @@
       </p:sp>
       <p:sp>
         <p:nvSpPr>
-          <p:cNvPr id="32" name="Text 30"/>
+          <p:cNvPr id="45" name="Text 38"/>
           <p:cNvSpPr/>
           <p:nvPr/>
         </p:nvSpPr>
@@ -2836,7 +3195,7 @@
       </p:sp>
       <p:sp>
         <p:nvSpPr>
-          <p:cNvPr id="33" name="Shape 31"/>
+          <p:cNvPr id="46" name="Shape 39"/>
           <p:cNvSpPr/>
           <p:nvPr/>
         </p:nvSpPr>
@@ -2856,7 +3215,7 @@
       </p:sp>
       <p:sp>
         <p:nvSpPr>
-          <p:cNvPr id="34" name="Text 32"/>
+          <p:cNvPr id="47" name="Text 40"/>
           <p:cNvSpPr/>
           <p:nvPr/>
         </p:nvSpPr>
@@ -2895,7 +3254,7 @@
       </p:sp>
       <p:sp>
         <p:nvSpPr>
-          <p:cNvPr id="35" name="Text 33"/>
+          <p:cNvPr id="48" name="Text 41"/>
           <p:cNvSpPr/>
           <p:nvPr/>
         </p:nvSpPr>
@@ -2934,7 +3293,7 @@
       </p:sp>
       <p:sp>
         <p:nvSpPr>
-          <p:cNvPr id="36" name="Text 34"/>
+          <p:cNvPr id="49" name="Text 42"/>
           <p:cNvSpPr/>
           <p:nvPr/>
         </p:nvSpPr>
@@ -3001,7 +3360,7 @@
       </p:sp>
       <p:sp>
         <p:nvSpPr>
-          <p:cNvPr id="37" name="Text 35"/>
+          <p:cNvPr id="50" name="Text 43"/>
           <p:cNvSpPr/>
           <p:nvPr/>
         </p:nvSpPr>
@@ -3866,16 +4225,40 @@
           </a:p>
         </p:txBody>
       </p:sp>
-      <p:sp>
-        <p:nvSpPr>
-          <p:cNvPr id="25" name="Shape 23"/>
+      <p:pic>
+        <p:nvPicPr>
+          <p:cNvPr id="25" name="Image 0" descr="preencoded.png">    </p:cNvPr>
+          <p:cNvPicPr>
+            <a:picLocks noChangeAspect="1"/>
+          </p:cNvPicPr>
+          <p:nvPr/>
+        </p:nvPicPr>
+        <p:blipFill>
+          <a:blip r:embed="rId1"/>
+          <a:stretch>
+            <a:fillRect/>
+          </a:stretch>
+        </p:blipFill>
+        <p:spPr>
+          <a:xfrm>
+            <a:off x="2971800" y="4626864"/>
+            <a:ext cx="347472" cy="347472"/>
+          </a:xfrm>
+          <a:prstGeom prst="rect">
+            <a:avLst/>
+          </a:prstGeom>
+        </p:spPr>
+      </p:pic>
+      <p:sp>
+        <p:nvSpPr>
+          <p:cNvPr id="26" name="Shape 23"/>
           <p:cNvSpPr/>
           <p:nvPr/>
         </p:nvSpPr>
         <p:spPr>
           <a:xfrm>
             <a:off x="6446520" y="1554480"/>
-            <a:ext cx="5257800" cy="1371600"/>
+            <a:ext cx="5257800" cy="1463040"/>
           </a:xfrm>
           <a:prstGeom prst="rect">
             <a:avLst/>
@@ -3900,14 +4283,14 @@
       </p:sp>
       <p:sp>
         <p:nvSpPr>
-          <p:cNvPr id="26" name="Shape 24"/>
+          <p:cNvPr id="27" name="Shape 24"/>
           <p:cNvSpPr/>
           <p:nvPr/>
         </p:nvSpPr>
         <p:spPr>
           <a:xfrm>
             <a:off x="6446520" y="1554480"/>
-            <a:ext cx="91440" cy="1371600"/>
+            <a:ext cx="91440" cy="1463040"/>
           </a:xfrm>
           <a:prstGeom prst="rect">
             <a:avLst/>
@@ -3920,13 +4303,13 @@
       </p:sp>
       <p:sp>
         <p:nvSpPr>
-          <p:cNvPr id="27" name="Shape 25"/>
-          <p:cNvSpPr/>
-          <p:nvPr/>
-        </p:nvSpPr>
-        <p:spPr>
-          <a:xfrm>
-            <a:off x="6702552" y="1783080"/>
+          <p:cNvPr id="28" name="Shape 25"/>
+          <p:cNvSpPr/>
+          <p:nvPr/>
+        </p:nvSpPr>
+        <p:spPr>
+          <a:xfrm>
+            <a:off x="6702552" y="1755648"/>
             <a:ext cx="502920" cy="502920"/>
           </a:xfrm>
           <a:prstGeom prst="ellipse">
@@ -3940,13 +4323,13 @@
       </p:sp>
       <p:sp>
         <p:nvSpPr>
-          <p:cNvPr id="28" name="Text 26"/>
-          <p:cNvSpPr/>
-          <p:nvPr/>
-        </p:nvSpPr>
-        <p:spPr>
-          <a:xfrm>
-            <a:off x="6702552" y="1783080"/>
+          <p:cNvPr id="29" name="Text 26"/>
+          <p:cNvSpPr/>
+          <p:nvPr/>
+        </p:nvSpPr>
+        <p:spPr>
+          <a:xfrm>
+            <a:off x="6702552" y="1755648"/>
             <a:ext cx="502920" cy="502920"/>
           </a:xfrm>
           <a:prstGeom prst="rect">
@@ -3979,13 +4362,13 @@
       </p:sp>
       <p:sp>
         <p:nvSpPr>
-          <p:cNvPr id="29" name="Text 27"/>
-          <p:cNvSpPr/>
-          <p:nvPr/>
-        </p:nvSpPr>
-        <p:spPr>
-          <a:xfrm>
-            <a:off x="7360920" y="1755648"/>
+          <p:cNvPr id="30" name="Text 27"/>
+          <p:cNvSpPr/>
+          <p:nvPr/>
+        </p:nvSpPr>
+        <p:spPr>
+          <a:xfrm>
+            <a:off x="7360920" y="1737360"/>
             <a:ext cx="4160520" cy="365760"/>
           </a:xfrm>
           <a:prstGeom prst="rect">
@@ -4016,16 +4399,40 @@
           </a:p>
         </p:txBody>
       </p:sp>
-      <p:sp>
-        <p:nvSpPr>
-          <p:cNvPr id="30" name="Text 28"/>
-          <p:cNvSpPr/>
-          <p:nvPr/>
-        </p:nvSpPr>
-        <p:spPr>
-          <a:xfrm>
-            <a:off x="7360920" y="2194560"/>
-            <a:ext cx="4160520" cy="548640"/>
+      <p:pic>
+        <p:nvPicPr>
+          <p:cNvPr id="31" name="Image 1" descr="preencoded.png">    </p:cNvPr>
+          <p:cNvPicPr>
+            <a:picLocks noChangeAspect="1"/>
+          </p:cNvPicPr>
+          <p:nvPr/>
+        </p:nvPicPr>
+        <p:blipFill>
+          <a:blip r:embed="rId2"/>
+          <a:stretch>
+            <a:fillRect/>
+          </a:stretch>
+        </p:blipFill>
+        <p:spPr>
+          <a:xfrm>
+            <a:off x="7360920" y="2331720"/>
+            <a:ext cx="292608" cy="292608"/>
+          </a:xfrm>
+          <a:prstGeom prst="rect">
+            <a:avLst/>
+          </a:prstGeom>
+        </p:spPr>
+      </p:pic>
+      <p:sp>
+        <p:nvSpPr>
+          <p:cNvPr id="32" name="Text 28"/>
+          <p:cNvSpPr/>
+          <p:nvPr/>
+        </p:nvSpPr>
+        <p:spPr>
+          <a:xfrm>
+            <a:off x="7708392" y="2331720"/>
+            <a:ext cx="1051560" cy="292608"/>
           </a:xfrm>
           <a:prstGeom prst="rect">
             <a:avLst/>
@@ -4041,7 +4448,7 @@
               <a:buNone/>
             </a:pPr>
             <a:r>
-              <a:rPr lang="en-US" sz="1400" dirty="0">
+              <a:rPr lang="en-US" sz="1150" dirty="0">
                 <a:solidFill>
                   <a:srgbClr val="243230"/>
                 </a:solidFill>
@@ -4049,15 +4456,141 @@
                 <a:ea typeface="Calibri" pitchFamily="34" charset="-122"/>
                 <a:cs typeface="Calibri" pitchFamily="34" charset="-120"/>
               </a:rPr>
-              <a:t>activation  ·  muscle  ·  fatigue</a:t>
-            </a:r>
-            <a:endParaRPr lang="en-US" sz="1400" dirty="0"/>
-          </a:p>
-        </p:txBody>
-      </p:sp>
-      <p:sp>
-        <p:nvSpPr>
-          <p:cNvPr id="31" name="Shape 29"/>
+              <a:t>activation</a:t>
+            </a:r>
+            <a:endParaRPr lang="en-US" sz="1150" dirty="0"/>
+          </a:p>
+        </p:txBody>
+      </p:sp>
+      <p:pic>
+        <p:nvPicPr>
+          <p:cNvPr id="33" name="Image 2" descr="preencoded.png">    </p:cNvPr>
+          <p:cNvPicPr>
+            <a:picLocks noChangeAspect="1"/>
+          </p:cNvPicPr>
+          <p:nvPr/>
+        </p:nvPicPr>
+        <p:blipFill>
+          <a:blip r:embed="rId3"/>
+          <a:stretch>
+            <a:fillRect/>
+          </a:stretch>
+        </p:blipFill>
+        <p:spPr>
+          <a:xfrm>
+            <a:off x="8778240" y="2331720"/>
+            <a:ext cx="292608" cy="292608"/>
+          </a:xfrm>
+          <a:prstGeom prst="rect">
+            <a:avLst/>
+          </a:prstGeom>
+        </p:spPr>
+      </p:pic>
+      <p:sp>
+        <p:nvSpPr>
+          <p:cNvPr id="34" name="Text 29"/>
+          <p:cNvSpPr/>
+          <p:nvPr/>
+        </p:nvSpPr>
+        <p:spPr>
+          <a:xfrm>
+            <a:off x="9125712" y="2331720"/>
+            <a:ext cx="1051560" cy="292608"/>
+          </a:xfrm>
+          <a:prstGeom prst="rect">
+            <a:avLst/>
+          </a:prstGeom>
+          <a:noFill/>
+          <a:ln/>
+        </p:spPr>
+        <p:txBody>
+          <a:bodyPr wrap="square" lIns="0" tIns="0" rIns="0" bIns="0" rtlCol="0" anchor="ctr"/>
+          <a:lstStyle/>
+          <a:p>
+            <a:pPr indent="0" marL="0">
+              <a:buNone/>
+            </a:pPr>
+            <a:r>
+              <a:rPr lang="en-US" sz="1150" dirty="0">
+                <a:solidFill>
+                  <a:srgbClr val="243230"/>
+                </a:solidFill>
+                <a:latin typeface="Calibri" pitchFamily="34" charset="0"/>
+                <a:ea typeface="Calibri" pitchFamily="34" charset="-122"/>
+                <a:cs typeface="Calibri" pitchFamily="34" charset="-120"/>
+              </a:rPr>
+              <a:t>muscle</a:t>
+            </a:r>
+            <a:endParaRPr lang="en-US" sz="1150" dirty="0"/>
+          </a:p>
+        </p:txBody>
+      </p:sp>
+      <p:pic>
+        <p:nvPicPr>
+          <p:cNvPr id="35" name="Image 3" descr="preencoded.png">    </p:cNvPr>
+          <p:cNvPicPr>
+            <a:picLocks noChangeAspect="1"/>
+          </p:cNvPicPr>
+          <p:nvPr/>
+        </p:nvPicPr>
+        <p:blipFill>
+          <a:blip r:embed="rId4"/>
+          <a:stretch>
+            <a:fillRect/>
+          </a:stretch>
+        </p:blipFill>
+        <p:spPr>
+          <a:xfrm>
+            <a:off x="10195560" y="2331720"/>
+            <a:ext cx="292608" cy="292608"/>
+          </a:xfrm>
+          <a:prstGeom prst="rect">
+            <a:avLst/>
+          </a:prstGeom>
+        </p:spPr>
+      </p:pic>
+      <p:sp>
+        <p:nvSpPr>
+          <p:cNvPr id="36" name="Text 30"/>
+          <p:cNvSpPr/>
+          <p:nvPr/>
+        </p:nvSpPr>
+        <p:spPr>
+          <a:xfrm>
+            <a:off x="10543032" y="2331720"/>
+            <a:ext cx="1051560" cy="292608"/>
+          </a:xfrm>
+          <a:prstGeom prst="rect">
+            <a:avLst/>
+          </a:prstGeom>
+          <a:noFill/>
+          <a:ln/>
+        </p:spPr>
+        <p:txBody>
+          <a:bodyPr wrap="square" lIns="0" tIns="0" rIns="0" bIns="0" rtlCol="0" anchor="ctr"/>
+          <a:lstStyle/>
+          <a:p>
+            <a:pPr indent="0" marL="0">
+              <a:buNone/>
+            </a:pPr>
+            <a:r>
+              <a:rPr lang="en-US" sz="1150" dirty="0">
+                <a:solidFill>
+                  <a:srgbClr val="243230"/>
+                </a:solidFill>
+                <a:latin typeface="Calibri" pitchFamily="34" charset="0"/>
+                <a:ea typeface="Calibri" pitchFamily="34" charset="-122"/>
+                <a:cs typeface="Calibri" pitchFamily="34" charset="-120"/>
+              </a:rPr>
+              <a:t>fatigue</a:t>
+            </a:r>
+            <a:endParaRPr lang="en-US" sz="1150" dirty="0"/>
+          </a:p>
+        </p:txBody>
+      </p:sp>
+      <p:sp>
+        <p:nvSpPr>
+          <p:cNvPr id="37" name="Shape 31"/>
           <p:cNvSpPr/>
           <p:nvPr/>
         </p:nvSpPr>
@@ -4089,7 +4622,7 @@
       </p:sp>
       <p:sp>
         <p:nvSpPr>
-          <p:cNvPr id="32" name="Shape 30"/>
+          <p:cNvPr id="38" name="Shape 32"/>
           <p:cNvSpPr/>
           <p:nvPr/>
         </p:nvSpPr>
@@ -4109,7 +4642,7 @@
       </p:sp>
       <p:sp>
         <p:nvSpPr>
-          <p:cNvPr id="33" name="Shape 31"/>
+          <p:cNvPr id="39" name="Shape 33"/>
           <p:cNvSpPr/>
           <p:nvPr/>
         </p:nvSpPr>
@@ -4129,7 +4662,7 @@
       </p:sp>
       <p:sp>
         <p:nvSpPr>
-          <p:cNvPr id="34" name="Text 32"/>
+          <p:cNvPr id="40" name="Text 34"/>
           <p:cNvSpPr/>
           <p:nvPr/>
         </p:nvSpPr>
@@ -4168,7 +4701,7 @@
       </p:sp>
       <p:sp>
         <p:nvSpPr>
-          <p:cNvPr id="35" name="Text 33"/>
+          <p:cNvPr id="41" name="Text 35"/>
           <p:cNvSpPr/>
           <p:nvPr/>
         </p:nvSpPr>
@@ -4207,7 +4740,7 @@
       </p:sp>
       <p:sp>
         <p:nvSpPr>
-          <p:cNvPr id="36" name="Text 34"/>
+          <p:cNvPr id="42" name="Text 36"/>
           <p:cNvSpPr/>
           <p:nvPr/>
         </p:nvSpPr>
@@ -4246,7 +4779,7 @@
       </p:sp>
       <p:sp>
         <p:nvSpPr>
-          <p:cNvPr id="37" name="Shape 35"/>
+          <p:cNvPr id="43" name="Shape 37"/>
           <p:cNvSpPr/>
           <p:nvPr/>
         </p:nvSpPr>
@@ -4271,7 +4804,7 @@
       </p:sp>
       <p:sp>
         <p:nvSpPr>
-          <p:cNvPr id="38" name="Text 36"/>
+          <p:cNvPr id="44" name="Text 38"/>
           <p:cNvSpPr/>
           <p:nvPr/>
         </p:nvSpPr>
@@ -4324,7 +4857,7 @@
       </p:sp>
       <p:sp>
         <p:nvSpPr>
-          <p:cNvPr id="39" name="Text 37"/>
+          <p:cNvPr id="45" name="Text 39"/>
           <p:cNvSpPr/>
           <p:nvPr/>
         </p:nvSpPr>

</xml_diff>

<commit_message>
Reframe adaptive-control narrative: questions-as-lens, not interpretation
Flip the master/subordinate framing: adaptive control supplies the
questions (unknown dynamics, disturbances, generalization) and we
observe how SATA answers them differently — contrasting two philosophies
of adaptation rather than interpreting SATA as a classical controller.
Deck S3 "Control Perspective" + "Questions from adaptive control"; S4
RQ3 "how does SATA address problems traditionally studied in adaptive
control"; README adds an adaptive-control-vs-SATA comparison table.

https://claude.ai/code/session_015i3CJw2uiqwwXT61q7nN5g
</commit_message>
<xml_diff>
--- a/docs/progress-report-v1.pptx
+++ b/docs/progress-report-v1.pptx
@@ -5091,7 +5091,7 @@
                 <a:ea typeface="Calibri" pitchFamily="34" charset="-122"/>
                 <a:cs typeface="Calibri" pitchFamily="34" charset="-120"/>
               </a:rPr>
-              <a:t>A feasible 3-phase study, with an optional extension — we interpret SATA, not redesign the RL.</a:t>
+              <a:t>A feasible 3-phase study, with an optional extension — we study SATA, not redesign the RL.</a:t>
             </a:r>
             <a:endParaRPr lang="en-US" sz="1300" dirty="0"/>
           </a:p>
@@ -5960,7 +5960,7 @@
                 <a:ea typeface="Calibri" pitchFamily="34" charset="-122"/>
                 <a:cs typeface="Calibri" pitchFamily="34" charset="-120"/>
               </a:rPr>
-              <a:t>Adaptive Interpretation</a:t>
+              <a:t>Control Perspective</a:t>
             </a:r>
             <a:endParaRPr lang="en-US" sz="1400" dirty="0"/>
           </a:p>
@@ -5999,6 +5999,23 @@
                 <a:ea typeface="Calibri" pitchFamily="34" charset="-122"/>
                 <a:cs typeface="Calibri" pitchFamily="34" charset="-120"/>
               </a:rPr>
+              <a:t>Questions from adaptive control:</a:t>
+            </a:r>
+            <a:endParaRPr lang="en-US" sz="1150" dirty="0"/>
+          </a:p>
+          <a:p>
+            <a:pPr indent="0" marL="0">
+              <a:buNone/>
+            </a:pPr>
+            <a:r>
+              <a:rPr lang="en-US" sz="1150" dirty="0">
+                <a:solidFill>
+                  <a:srgbClr val="243230"/>
+                </a:solidFill>
+                <a:latin typeface="Calibri" pitchFamily="34" charset="0"/>
+                <a:ea typeface="Calibri" pitchFamily="34" charset="-122"/>
+                <a:cs typeface="Calibri" pitchFamily="34" charset="-120"/>
+              </a:rPr>
               <a:t>Growth ↔ gain scheduling</a:t>
             </a:r>
             <a:endParaRPr lang="en-US" sz="1150" dirty="0"/>
@@ -6016,7 +6033,7 @@
                 <a:ea typeface="Calibri" pitchFamily="34" charset="-122"/>
                 <a:cs typeface="Calibri" pitchFamily="34" charset="-120"/>
               </a:rPr>
-              <a:t>Fatigue ↔ internal feedback</a:t>
+              <a:t>Fatigue ↔ feedback</a:t>
             </a:r>
             <a:endParaRPr lang="en-US" sz="1150" dirty="0"/>
           </a:p>
@@ -6033,30 +6050,7 @@
                 <a:ea typeface="Calibri" pitchFamily="34" charset="-122"/>
                 <a:cs typeface="Calibri" pitchFamily="34" charset="-120"/>
               </a:rPr>
-              <a:t>Torque limit ↔ progressive constraint modulation</a:t>
-            </a:r>
-            <a:endParaRPr lang="en-US" sz="1150" dirty="0"/>
-          </a:p>
-          <a:p>
-            <a:pPr indent="0" marL="0">
-              <a:buNone/>
-            </a:pPr>
-            <a:endParaRPr lang="en-US" sz="1150" dirty="0"/>
-          </a:p>
-          <a:p>
-            <a:pPr indent="0" marL="0">
-              <a:buNone/>
-            </a:pPr>
-            <a:r>
-              <a:rPr lang="en-US" sz="1150" dirty="0">
-                <a:solidFill>
-                  <a:srgbClr val="243230"/>
-                </a:solidFill>
-                <a:latin typeface="Calibri" pitchFamily="34" charset="0"/>
-                <a:ea typeface="Calibri" pitchFamily="34" charset="-122"/>
-                <a:cs typeface="Calibri" pitchFamily="34" charset="-120"/>
-              </a:rPr>
-              <a:t>(analogies, not claims)</a:t>
+              <a:t>Torque modulation ↔ robustness</a:t>
             </a:r>
             <a:endParaRPr lang="en-US" sz="1150" dirty="0"/>
           </a:p>
@@ -6132,7 +6126,7 @@
                 <a:ea typeface="Calibri" pitchFamily="34" charset="-122"/>
                 <a:cs typeface="Calibri" pitchFamily="34" charset="-120"/>
               </a:rPr>
-              <a:t>analysis &amp; discussion</a:t>
+              <a:t>comparison &amp; discussion</a:t>
             </a:r>
             <a:endParaRPr lang="en-US" sz="1150" dirty="0"/>
           </a:p>
@@ -7323,7 +7317,7 @@
                 <a:ea typeface="Calibri" pitchFamily="34" charset="-122"/>
                 <a:cs typeface="Calibri" pitchFamily="34" charset="-120"/>
               </a:rPr>
-              <a:t>Adaptive control interpretation</a:t>
+              <a:t>Control-perspective comparison</a:t>
             </a:r>
             <a:endParaRPr lang="en-US" sz="1500" dirty="0"/>
           </a:p>
@@ -7565,8 +7559,8 @@
         </p:nvSpPr>
         <p:spPr>
           <a:xfrm>
-            <a:off x="6510528" y="3291840"/>
-            <a:ext cx="2249424" cy="594360"/>
+            <a:off x="6510528" y="3255264"/>
+            <a:ext cx="2249424" cy="658368"/>
           </a:xfrm>
           <a:prstGeom prst="rect">
             <a:avLst/>
@@ -7582,7 +7576,7 @@
               <a:buNone/>
             </a:pPr>
             <a:r>
-              <a:rPr lang="en-US" sz="1300" dirty="0">
+              <a:rPr lang="en-US" sz="1200" dirty="0">
                 <a:solidFill>
                   <a:srgbClr val="243230"/>
                 </a:solidFill>
@@ -7592,7 +7586,7 @@
               </a:rPr>
               <a:t>Why torque control?</a:t>
             </a:r>
-            <a:endParaRPr lang="en-US" sz="1300" dirty="0"/>
+            <a:endParaRPr lang="en-US" sz="1200" dirty="0"/>
           </a:p>
         </p:txBody>
       </p:sp>
@@ -7695,8 +7689,8 @@
         </p:nvSpPr>
         <p:spPr>
           <a:xfrm>
-            <a:off x="9308592" y="3291840"/>
-            <a:ext cx="2249424" cy="594360"/>
+            <a:off x="9308592" y="3255264"/>
+            <a:ext cx="2249424" cy="658368"/>
           </a:xfrm>
           <a:prstGeom prst="rect">
             <a:avLst/>
@@ -7712,7 +7706,7 @@
               <a:buNone/>
             </a:pPr>
             <a:r>
-              <a:rPr lang="en-US" sz="1300" dirty="0">
+              <a:rPr lang="en-US" sz="1200" dirty="0">
                 <a:solidFill>
                   <a:srgbClr val="243230"/>
                 </a:solidFill>
@@ -7722,7 +7716,7 @@
               </a:rPr>
               <a:t>What creates adaptation?</a:t>
             </a:r>
-            <a:endParaRPr lang="en-US" sz="1300" dirty="0"/>
+            <a:endParaRPr lang="en-US" sz="1200" dirty="0"/>
           </a:p>
         </p:txBody>
       </p:sp>
@@ -7825,8 +7819,8 @@
         </p:nvSpPr>
         <p:spPr>
           <a:xfrm>
-            <a:off x="6510528" y="4663440"/>
-            <a:ext cx="2249424" cy="594360"/>
+            <a:off x="6510528" y="4626864"/>
+            <a:ext cx="2249424" cy="658368"/>
           </a:xfrm>
           <a:prstGeom prst="rect">
             <a:avLst/>
@@ -7842,7 +7836,7 @@
               <a:buNone/>
             </a:pPr>
             <a:r>
-              <a:rPr lang="en-US" sz="1300" dirty="0">
+              <a:rPr lang="en-US" sz="1200" dirty="0">
                 <a:solidFill>
                   <a:srgbClr val="243230"/>
                 </a:solidFill>
@@ -7850,9 +7844,9 @@
                 <a:ea typeface="Calibri" pitchFamily="34" charset="-122"/>
                 <a:cs typeface="Calibri" pitchFamily="34" charset="-120"/>
               </a:rPr>
-              <a:t>How does it relate to adaptive control?</a:t>
-            </a:r>
-            <a:endParaRPr lang="en-US" sz="1300" dirty="0"/>
+              <a:t>How does SATA address problems traditionally studied in adaptive control?</a:t>
+            </a:r>
+            <a:endParaRPr lang="en-US" sz="1200" dirty="0"/>
           </a:p>
         </p:txBody>
       </p:sp>
@@ -7955,8 +7949,8 @@
         </p:nvSpPr>
         <p:spPr>
           <a:xfrm>
-            <a:off x="9308592" y="4663440"/>
-            <a:ext cx="2249424" cy="594360"/>
+            <a:off x="9308592" y="4626864"/>
+            <a:ext cx="2249424" cy="658368"/>
           </a:xfrm>
           <a:prstGeom prst="rect">
             <a:avLst/>
@@ -7972,7 +7966,7 @@
               <a:buNone/>
             </a:pPr>
             <a:r>
-              <a:rPr lang="en-US" sz="1300" dirty="0">
+              <a:rPr lang="en-US" sz="1200" dirty="0">
                 <a:solidFill>
                   <a:srgbClr val="243230"/>
                 </a:solidFill>
@@ -7982,7 +7976,7 @@
               </a:rPr>
               <a:t>Can lightweight compensation help?</a:t>
             </a:r>
-            <a:endParaRPr lang="en-US" sz="1300" dirty="0"/>
+            <a:endParaRPr lang="en-US" sz="1200" dirty="0"/>
           </a:p>
         </p:txBody>
       </p:sp>

</xml_diff>

<commit_message>
Visual polish: cleaner terrain scene, title wrap, spacing/line-height
Layout-only (content unchanged): redraw S1 scene with a dashed soft-
ground line so captions no longer collide with the dip; shrink the title
to two balanced lines and tighten the cover block; spread S2's flow to
match the right column height (less top-heavy); add modest line spacing
to dense text blocks for reading comfort.

https://claude.ai/code/session_015i3CJw2uiqwwXT61q7nN5g
</commit_message>
<xml_diff>
--- a/docs/progress-report-v1.pptx
+++ b/docs/progress-report-v1.pptx
@@ -1638,8 +1638,8 @@
         </p:nvSpPr>
         <p:spPr>
           <a:xfrm>
-            <a:off x="640080" y="2240280"/>
-            <a:ext cx="7772400" cy="1554480"/>
+            <a:off x="640080" y="2468880"/>
+            <a:ext cx="7955280" cy="1280160"/>
           </a:xfrm>
           <a:prstGeom prst="rect">
             <a:avLst/>
@@ -1653,12 +1653,12 @@
           <a:p>
             <a:pPr indent="0" marL="0">
               <a:lnSpc>
-                <a:spcPct val="105000"/>
+                <a:spcPct val="108000"/>
               </a:lnSpc>
               <a:buNone/>
             </a:pPr>
             <a:r>
-              <a:rPr lang="en-US" sz="3400" b="1" dirty="0">
+              <a:rPr lang="en-US" sz="3100" b="1" dirty="0">
                 <a:solidFill>
                   <a:srgbClr val="FFFFFF"/>
                 </a:solidFill>
@@ -1668,17 +1668,17 @@
               </a:rPr>
               <a:t>Bio-inspired Adaptive Locomotion</a:t>
             </a:r>
-            <a:endParaRPr lang="en-US" sz="3400" dirty="0"/>
+            <a:endParaRPr lang="en-US" sz="3100" dirty="0"/>
           </a:p>
           <a:p>
             <a:pPr indent="0" marL="0">
               <a:lnSpc>
-                <a:spcPct val="105000"/>
+                <a:spcPct val="108000"/>
               </a:lnSpc>
               <a:buNone/>
             </a:pPr>
             <a:r>
-              <a:rPr lang="en-US" sz="3400" b="1" dirty="0">
+              <a:rPr lang="en-US" sz="3100" b="1" dirty="0">
                 <a:solidFill>
                   <a:srgbClr val="FFFFFF"/>
                 </a:solidFill>
@@ -1688,7 +1688,7 @@
               </a:rPr>
               <a:t>via Torque-based Learning</a:t>
             </a:r>
-            <a:endParaRPr lang="en-US" sz="3400" dirty="0"/>
+            <a:endParaRPr lang="en-US" sz="3100" dirty="0"/>
           </a:p>
         </p:txBody>
       </p:sp>
@@ -1700,7 +1700,7 @@
         </p:nvSpPr>
         <p:spPr>
           <a:xfrm>
-            <a:off x="658368" y="3977640"/>
+            <a:off x="658368" y="3657600"/>
             <a:ext cx="7680960" cy="457200"/>
           </a:xfrm>
           <a:prstGeom prst="rect">
@@ -1739,7 +1739,7 @@
         </p:nvSpPr>
         <p:spPr>
           <a:xfrm>
-            <a:off x="676656" y="4754880"/>
+            <a:off x="676656" y="4434840"/>
             <a:ext cx="1828800" cy="45720"/>
           </a:xfrm>
           <a:prstGeom prst="rect">
@@ -1759,7 +1759,7 @@
         </p:nvSpPr>
         <p:spPr>
           <a:xfrm>
-            <a:off x="640080" y="4983480"/>
+            <a:off x="640080" y="4663440"/>
             <a:ext cx="7315200" cy="411480"/>
           </a:xfrm>
           <a:prstGeom prst="rect">
@@ -1798,7 +1798,7 @@
         </p:nvSpPr>
         <p:spPr>
           <a:xfrm>
-            <a:off x="640080" y="5413248"/>
+            <a:off x="640080" y="5093208"/>
             <a:ext cx="7315200" cy="365760"/>
           </a:xfrm>
           <a:prstGeom prst="rect">
@@ -2092,6 +2092,9 @@
           <a:lstStyle/>
           <a:p>
             <a:pPr indent="0" marL="0">
+              <a:lnSpc>
+                <a:spcPct val="108000"/>
+              </a:lnSpc>
               <a:buNone/>
             </a:pPr>
             <a:r>
@@ -2144,8 +2147,8 @@
         </p:nvSpPr>
         <p:spPr>
           <a:xfrm>
-            <a:off x="658368" y="2834640"/>
-            <a:ext cx="4663440" cy="256032"/>
+            <a:off x="658368" y="2852928"/>
+            <a:ext cx="4663440" cy="237744"/>
           </a:xfrm>
           <a:prstGeom prst="rect">
             <a:avLst/>
@@ -2174,33 +2177,10 @@
             <a:endParaRPr lang="en-US" sz="1000" dirty="0"/>
           </a:p>
         </p:txBody>
-      </p:sp>
-      <p:sp>
-        <p:nvSpPr>
-          <p:cNvPr id="12" name="Shape 10"/>
-          <p:cNvSpPr/>
-          <p:nvPr/>
-        </p:nvSpPr>
-        <p:spPr>
-          <a:xfrm>
-            <a:off x="777240" y="3675888"/>
-            <a:ext cx="1325880" cy="0"/>
-          </a:xfrm>
-          <a:prstGeom prst="line">
-            <a:avLst/>
-          </a:prstGeom>
-          <a:noFill/>
-          <a:ln w="38100">
-            <a:solidFill>
-              <a:srgbClr val="9A8C7A"/>
-            </a:solidFill>
-            <a:prstDash val="solid"/>
-          </a:ln>
-        </p:spPr>
       </p:sp>
       <p:pic>
         <p:nvPicPr>
-          <p:cNvPr id="13" name="Image 0" descr="preencoded.png">    </p:cNvPr>
+          <p:cNvPr id="12" name="Image 0" descr="preencoded.png">    </p:cNvPr>
           <p:cNvPicPr>
             <a:picLocks noChangeAspect="1"/>
           </p:cNvPicPr>
@@ -2214,7 +2194,7 @@
         </p:blipFill>
         <p:spPr>
           <a:xfrm>
-            <a:off x="1078992" y="3127248"/>
+            <a:off x="1097280" y="3163824"/>
             <a:ext cx="512064" cy="512064"/>
           </a:xfrm>
           <a:prstGeom prst="rect">
@@ -2224,14 +2204,37 @@
       </p:pic>
       <p:sp>
         <p:nvSpPr>
+          <p:cNvPr id="13" name="Shape 10"/>
+          <p:cNvSpPr/>
+          <p:nvPr/>
+        </p:nvSpPr>
+        <p:spPr>
+          <a:xfrm>
+            <a:off x="731520" y="3703320"/>
+            <a:ext cx="1417320" cy="0"/>
+          </a:xfrm>
+          <a:prstGeom prst="line">
+            <a:avLst/>
+          </a:prstGeom>
+          <a:noFill/>
+          <a:ln w="38100">
+            <a:solidFill>
+              <a:srgbClr val="9A8C7A"/>
+            </a:solidFill>
+            <a:prstDash val="solid"/>
+          </a:ln>
+        </p:spPr>
+      </p:sp>
+      <p:sp>
+        <p:nvSpPr>
           <p:cNvPr id="14" name="Text 11"/>
           <p:cNvSpPr/>
           <p:nvPr/>
         </p:nvSpPr>
         <p:spPr>
           <a:xfrm>
-            <a:off x="685800" y="3703320"/>
-            <a:ext cx="1463040" cy="237744"/>
+            <a:off x="640080" y="3739896"/>
+            <a:ext cx="1600200" cy="219456"/>
           </a:xfrm>
           <a:prstGeom prst="rect">
             <a:avLst/>
@@ -2247,7 +2250,7 @@
               <a:buNone/>
             </a:pPr>
             <a:r>
-              <a:rPr lang="en-US" sz="950" dirty="0">
+              <a:rPr lang="en-US" sz="1000" dirty="0">
                 <a:solidFill>
                   <a:srgbClr val="7C8A87"/>
                 </a:solidFill>
@@ -2257,7 +2260,7 @@
               </a:rPr>
               <a:t>firm · known</a:t>
             </a:r>
-            <a:endParaRPr lang="en-US" sz="950" dirty="0"/>
+            <a:endParaRPr lang="en-US" sz="1000" dirty="0"/>
           </a:p>
         </p:txBody>
       </p:sp>
@@ -2277,109 +2280,17 @@
         </p:blipFill>
         <p:spPr>
           <a:xfrm>
-            <a:off x="2286000" y="3310128"/>
-            <a:ext cx="457200" cy="329184"/>
+            <a:off x="2395728" y="3346704"/>
+            <a:ext cx="457200" cy="310896"/>
           </a:xfrm>
           <a:prstGeom prst="rect">
             <a:avLst/>
           </a:prstGeom>
         </p:spPr>
       </p:pic>
-      <p:sp>
-        <p:nvSpPr>
-          <p:cNvPr id="16" name="Shape 12"/>
-          <p:cNvSpPr/>
-          <p:nvPr/>
-        </p:nvSpPr>
-        <p:spPr>
-          <a:xfrm>
-            <a:off x="3063240" y="3675888"/>
-            <a:ext cx="777240" cy="0"/>
-          </a:xfrm>
-          <a:prstGeom prst="line">
-            <a:avLst/>
-          </a:prstGeom>
-          <a:noFill/>
-          <a:ln w="38100">
-            <a:solidFill>
-              <a:srgbClr val="B0573F"/>
-            </a:solidFill>
-            <a:prstDash val="solid"/>
-          </a:ln>
-        </p:spPr>
-      </p:sp>
-      <p:sp>
-        <p:nvSpPr>
-          <p:cNvPr id="17" name="Shape 13"/>
-          <p:cNvSpPr/>
-          <p:nvPr/>
-        </p:nvSpPr>
-        <p:spPr>
-          <a:xfrm>
-            <a:off x="3840480" y="3675888"/>
-            <a:ext cx="292608" cy="237744"/>
-          </a:xfrm>
-          <a:prstGeom prst="line">
-            <a:avLst/>
-          </a:prstGeom>
-          <a:noFill/>
-          <a:ln w="38100">
-            <a:solidFill>
-              <a:srgbClr val="B0573F"/>
-            </a:solidFill>
-            <a:prstDash val="solid"/>
-          </a:ln>
-        </p:spPr>
-      </p:sp>
-      <p:sp>
-        <p:nvSpPr>
-          <p:cNvPr id="18" name="Shape 14"/>
-          <p:cNvSpPr/>
-          <p:nvPr/>
-        </p:nvSpPr>
-        <p:spPr>
-          <a:xfrm>
-            <a:off x="4133088" y="3913632"/>
-            <a:ext cx="274320" cy="-237744"/>
-          </a:xfrm>
-          <a:prstGeom prst="line">
-            <a:avLst/>
-          </a:prstGeom>
-          <a:noFill/>
-          <a:ln w="38100">
-            <a:solidFill>
-              <a:srgbClr val="B0573F"/>
-            </a:solidFill>
-            <a:prstDash val="solid"/>
-          </a:ln>
-        </p:spPr>
-      </p:sp>
-      <p:sp>
-        <p:nvSpPr>
-          <p:cNvPr id="19" name="Shape 15"/>
-          <p:cNvSpPr/>
-          <p:nvPr/>
-        </p:nvSpPr>
-        <p:spPr>
-          <a:xfrm>
-            <a:off x="4407408" y="3675888"/>
-            <a:ext cx="822960" cy="0"/>
-          </a:xfrm>
-          <a:prstGeom prst="line">
-            <a:avLst/>
-          </a:prstGeom>
-          <a:noFill/>
-          <a:ln w="38100">
-            <a:solidFill>
-              <a:srgbClr val="B0573F"/>
-            </a:solidFill>
-            <a:prstDash val="solid"/>
-          </a:ln>
-        </p:spPr>
-      </p:sp>
       <p:pic>
         <p:nvPicPr>
-          <p:cNvPr id="20" name="Image 2" descr="preencoded.png">    </p:cNvPr>
+          <p:cNvPr id="16" name="Image 2" descr="preencoded.png">    </p:cNvPr>
           <p:cNvPicPr>
             <a:picLocks noChangeAspect="1"/>
           </p:cNvPicPr>
@@ -2393,7 +2304,7 @@
         </p:blipFill>
         <p:spPr>
           <a:xfrm>
-            <a:off x="3611880" y="3127248"/>
+            <a:off x="3611880" y="3163824"/>
             <a:ext cx="512064" cy="512064"/>
           </a:xfrm>
           <a:prstGeom prst="rect">
@@ -2403,7 +2314,7 @@
       </p:pic>
       <p:pic>
         <p:nvPicPr>
-          <p:cNvPr id="21" name="Image 3" descr="preencoded.png">    </p:cNvPr>
+          <p:cNvPr id="17" name="Image 3" descr="preencoded.png">    </p:cNvPr>
           <p:cNvPicPr>
             <a:picLocks noChangeAspect="1"/>
           </p:cNvPicPr>
@@ -2417,8 +2328,8 @@
         </p:blipFill>
         <p:spPr>
           <a:xfrm>
-            <a:off x="4160520" y="3054096"/>
-            <a:ext cx="274320" cy="384048"/>
+            <a:off x="4242816" y="2999232"/>
+            <a:ext cx="256032" cy="365760"/>
           </a:xfrm>
           <a:prstGeom prst="rect">
             <a:avLst/>
@@ -2427,7 +2338,7 @@
       </p:pic>
       <p:pic>
         <p:nvPicPr>
-          <p:cNvPr id="22" name="Image 4" descr="preencoded.png">    </p:cNvPr>
+          <p:cNvPr id="18" name="Image 4" descr="preencoded.png">    </p:cNvPr>
           <p:cNvPicPr>
             <a:picLocks noChangeAspect="1"/>
           </p:cNvPicPr>
@@ -2441,8 +2352,8 @@
         </p:blipFill>
         <p:spPr>
           <a:xfrm>
-            <a:off x="4956048" y="3127248"/>
-            <a:ext cx="237744" cy="237744"/>
+            <a:off x="5047488" y="3182112"/>
+            <a:ext cx="219456" cy="219456"/>
           </a:xfrm>
           <a:prstGeom prst="rect">
             <a:avLst/>
@@ -2451,14 +2362,37 @@
       </p:pic>
       <p:sp>
         <p:nvSpPr>
-          <p:cNvPr id="23" name="Text 16"/>
-          <p:cNvSpPr/>
-          <p:nvPr/>
-        </p:nvSpPr>
-        <p:spPr>
-          <a:xfrm>
-            <a:off x="3063240" y="3703320"/>
-            <a:ext cx="2194560" cy="237744"/>
+          <p:cNvPr id="19" name="Shape 12"/>
+          <p:cNvSpPr/>
+          <p:nvPr/>
+        </p:nvSpPr>
+        <p:spPr>
+          <a:xfrm>
+            <a:off x="3154680" y="3703320"/>
+            <a:ext cx="2057400" cy="0"/>
+          </a:xfrm>
+          <a:prstGeom prst="line">
+            <a:avLst/>
+          </a:prstGeom>
+          <a:noFill/>
+          <a:ln w="38100">
+            <a:solidFill>
+              <a:srgbClr val="B0573F"/>
+            </a:solidFill>
+            <a:prstDash val="dash"/>
+          </a:ln>
+        </p:spPr>
+      </p:sp>
+      <p:sp>
+        <p:nvSpPr>
+          <p:cNvPr id="20" name="Text 13"/>
+          <p:cNvSpPr/>
+          <p:nvPr/>
+        </p:nvSpPr>
+        <p:spPr>
+          <a:xfrm>
+            <a:off x="3246120" y="3739896"/>
+            <a:ext cx="1874520" cy="219456"/>
           </a:xfrm>
           <a:prstGeom prst="rect">
             <a:avLst/>
@@ -2474,7 +2408,7 @@
               <a:buNone/>
             </a:pPr>
             <a:r>
-              <a:rPr lang="en-US" sz="950" dirty="0">
+              <a:rPr lang="en-US" sz="1000" dirty="0">
                 <a:solidFill>
                   <a:srgbClr val="B0573F"/>
                 </a:solidFill>
@@ -2484,13 +2418,13 @@
               </a:rPr>
               <a:t>soft · unknown</a:t>
             </a:r>
-            <a:endParaRPr lang="en-US" sz="950" dirty="0"/>
-          </a:p>
-        </p:txBody>
-      </p:sp>
-      <p:sp>
-        <p:nvSpPr>
-          <p:cNvPr id="24" name="Shape 17"/>
+            <a:endParaRPr lang="en-US" sz="1000" dirty="0"/>
+          </a:p>
+        </p:txBody>
+      </p:sp>
+      <p:sp>
+        <p:nvSpPr>
+          <p:cNvPr id="21" name="Shape 14"/>
           <p:cNvSpPr/>
           <p:nvPr/>
         </p:nvSpPr>
@@ -2510,7 +2444,7 @@
       </p:sp>
       <p:sp>
         <p:nvSpPr>
-          <p:cNvPr id="25" name="Text 18"/>
+          <p:cNvPr id="22" name="Text 15"/>
           <p:cNvSpPr/>
           <p:nvPr/>
         </p:nvSpPr>
@@ -2549,7 +2483,7 @@
       </p:sp>
       <p:sp>
         <p:nvSpPr>
-          <p:cNvPr id="26" name="Shape 19"/>
+          <p:cNvPr id="23" name="Shape 16"/>
           <p:cNvSpPr/>
           <p:nvPr/>
         </p:nvSpPr>
@@ -2569,7 +2503,7 @@
       </p:sp>
       <p:sp>
         <p:nvSpPr>
-          <p:cNvPr id="27" name="Text 20"/>
+          <p:cNvPr id="24" name="Text 17"/>
           <p:cNvSpPr/>
           <p:nvPr/>
         </p:nvSpPr>
@@ -2608,7 +2542,7 @@
       </p:sp>
       <p:sp>
         <p:nvSpPr>
-          <p:cNvPr id="28" name="Shape 21"/>
+          <p:cNvPr id="25" name="Shape 18"/>
           <p:cNvSpPr/>
           <p:nvPr/>
         </p:nvSpPr>
@@ -2628,7 +2562,7 @@
       </p:sp>
       <p:sp>
         <p:nvSpPr>
-          <p:cNvPr id="29" name="Text 22"/>
+          <p:cNvPr id="26" name="Text 19"/>
           <p:cNvSpPr/>
           <p:nvPr/>
         </p:nvSpPr>
@@ -2667,7 +2601,7 @@
       </p:sp>
       <p:sp>
         <p:nvSpPr>
-          <p:cNvPr id="30" name="Shape 23"/>
+          <p:cNvPr id="27" name="Shape 20"/>
           <p:cNvSpPr/>
           <p:nvPr/>
         </p:nvSpPr>
@@ -2692,7 +2626,7 @@
       </p:sp>
       <p:sp>
         <p:nvSpPr>
-          <p:cNvPr id="31" name="Text 24"/>
+          <p:cNvPr id="28" name="Text 21"/>
           <p:cNvSpPr/>
           <p:nvPr/>
         </p:nvSpPr>
@@ -2731,7 +2665,7 @@
       </p:sp>
       <p:sp>
         <p:nvSpPr>
-          <p:cNvPr id="32" name="Shape 25"/>
+          <p:cNvPr id="29" name="Shape 22"/>
           <p:cNvSpPr/>
           <p:nvPr/>
         </p:nvSpPr>
@@ -2756,7 +2690,7 @@
       </p:sp>
       <p:sp>
         <p:nvSpPr>
-          <p:cNvPr id="33" name="Text 26"/>
+          <p:cNvPr id="30" name="Text 23"/>
           <p:cNvSpPr/>
           <p:nvPr/>
         </p:nvSpPr>
@@ -2795,7 +2729,7 @@
       </p:sp>
       <p:sp>
         <p:nvSpPr>
-          <p:cNvPr id="34" name="Text 27"/>
+          <p:cNvPr id="31" name="Text 24"/>
           <p:cNvSpPr/>
           <p:nvPr/>
         </p:nvSpPr>
@@ -2831,7 +2765,7 @@
       </p:sp>
       <p:sp>
         <p:nvSpPr>
-          <p:cNvPr id="35" name="Text 28"/>
+          <p:cNvPr id="32" name="Text 25"/>
           <p:cNvSpPr/>
           <p:nvPr/>
         </p:nvSpPr>
@@ -2867,7 +2801,7 @@
       </p:sp>
       <p:sp>
         <p:nvSpPr>
-          <p:cNvPr id="36" name="Shape 29"/>
+          <p:cNvPr id="33" name="Shape 26"/>
           <p:cNvSpPr/>
           <p:nvPr/>
         </p:nvSpPr>
@@ -2892,7 +2826,7 @@
       </p:sp>
       <p:sp>
         <p:nvSpPr>
-          <p:cNvPr id="37" name="Text 30"/>
+          <p:cNvPr id="34" name="Text 27"/>
           <p:cNvSpPr/>
           <p:nvPr/>
         </p:nvSpPr>
@@ -2931,7 +2865,7 @@
       </p:sp>
       <p:sp>
         <p:nvSpPr>
-          <p:cNvPr id="38" name="Shape 31"/>
+          <p:cNvPr id="35" name="Shape 28"/>
           <p:cNvSpPr/>
           <p:nvPr/>
         </p:nvSpPr>
@@ -2956,7 +2890,7 @@
       </p:sp>
       <p:sp>
         <p:nvSpPr>
-          <p:cNvPr id="39" name="Text 32"/>
+          <p:cNvPr id="36" name="Text 29"/>
           <p:cNvSpPr/>
           <p:nvPr/>
         </p:nvSpPr>
@@ -2995,7 +2929,7 @@
       </p:sp>
       <p:sp>
         <p:nvSpPr>
-          <p:cNvPr id="40" name="Text 33"/>
+          <p:cNvPr id="37" name="Text 30"/>
           <p:cNvSpPr/>
           <p:nvPr/>
         </p:nvSpPr>
@@ -3031,7 +2965,7 @@
       </p:sp>
       <p:sp>
         <p:nvSpPr>
-          <p:cNvPr id="41" name="Text 34"/>
+          <p:cNvPr id="38" name="Text 31"/>
           <p:cNvSpPr/>
           <p:nvPr/>
         </p:nvSpPr>
@@ -3067,7 +3001,7 @@
       </p:sp>
       <p:sp>
         <p:nvSpPr>
-          <p:cNvPr id="42" name="Shape 35"/>
+          <p:cNvPr id="39" name="Shape 32"/>
           <p:cNvSpPr/>
           <p:nvPr/>
         </p:nvSpPr>
@@ -3092,7 +3026,7 @@
       </p:sp>
       <p:sp>
         <p:nvSpPr>
-          <p:cNvPr id="43" name="Text 36"/>
+          <p:cNvPr id="40" name="Text 33"/>
           <p:cNvSpPr/>
           <p:nvPr/>
         </p:nvSpPr>
@@ -3131,7 +3065,7 @@
       </p:sp>
       <p:sp>
         <p:nvSpPr>
-          <p:cNvPr id="44" name="Shape 37"/>
+          <p:cNvPr id="41" name="Shape 34"/>
           <p:cNvSpPr/>
           <p:nvPr/>
         </p:nvSpPr>
@@ -3156,7 +3090,7 @@
       </p:sp>
       <p:sp>
         <p:nvSpPr>
-          <p:cNvPr id="45" name="Text 38"/>
+          <p:cNvPr id="42" name="Text 35"/>
           <p:cNvSpPr/>
           <p:nvPr/>
         </p:nvSpPr>
@@ -3195,7 +3129,7 @@
       </p:sp>
       <p:sp>
         <p:nvSpPr>
-          <p:cNvPr id="46" name="Shape 39"/>
+          <p:cNvPr id="43" name="Shape 36"/>
           <p:cNvSpPr/>
           <p:nvPr/>
         </p:nvSpPr>
@@ -3215,7 +3149,7 @@
       </p:sp>
       <p:sp>
         <p:nvSpPr>
-          <p:cNvPr id="47" name="Text 40"/>
+          <p:cNvPr id="44" name="Text 37"/>
           <p:cNvSpPr/>
           <p:nvPr/>
         </p:nvSpPr>
@@ -3254,7 +3188,7 @@
       </p:sp>
       <p:sp>
         <p:nvSpPr>
-          <p:cNvPr id="48" name="Text 41"/>
+          <p:cNvPr id="45" name="Text 38"/>
           <p:cNvSpPr/>
           <p:nvPr/>
         </p:nvSpPr>
@@ -3293,7 +3227,7 @@
       </p:sp>
       <p:sp>
         <p:nvSpPr>
-          <p:cNvPr id="49" name="Text 42"/>
+          <p:cNvPr id="46" name="Text 39"/>
           <p:cNvSpPr/>
           <p:nvPr/>
         </p:nvSpPr>
@@ -3360,7 +3294,7 @@
       </p:sp>
       <p:sp>
         <p:nvSpPr>
-          <p:cNvPr id="50" name="Text 43"/>
+          <p:cNvPr id="47" name="Text 40"/>
           <p:cNvSpPr/>
           <p:nvPr/>
         </p:nvSpPr>
@@ -3679,7 +3613,7 @@
         </p:nvSpPr>
         <p:spPr>
           <a:xfrm>
-            <a:off x="3954780" y="2157984"/>
+            <a:off x="3954780" y="2167128"/>
             <a:ext cx="365760" cy="256032"/>
           </a:xfrm>
           <a:prstGeom prst="rect">
@@ -3715,7 +3649,7 @@
         </p:nvSpPr>
         <p:spPr>
           <a:xfrm>
-            <a:off x="2514600" y="2331720"/>
+            <a:off x="2514600" y="2441448"/>
             <a:ext cx="3246120" cy="548640"/>
           </a:xfrm>
           <a:prstGeom prst="rect">
@@ -3747,7 +3681,7 @@
         </p:nvSpPr>
         <p:spPr>
           <a:xfrm>
-            <a:off x="2514600" y="2331720"/>
+            <a:off x="2514600" y="2441448"/>
             <a:ext cx="3246120" cy="548640"/>
           </a:xfrm>
           <a:prstGeom prst="rect">
@@ -3786,7 +3720,7 @@
         </p:nvSpPr>
         <p:spPr>
           <a:xfrm>
-            <a:off x="3954780" y="2889504"/>
+            <a:off x="3954780" y="3008376"/>
             <a:ext cx="365760" cy="256032"/>
           </a:xfrm>
           <a:prstGeom prst="rect">
@@ -3822,7 +3756,7 @@
         </p:nvSpPr>
         <p:spPr>
           <a:xfrm>
-            <a:off x="2514600" y="3063240"/>
+            <a:off x="2514600" y="3282696"/>
             <a:ext cx="3246120" cy="548640"/>
           </a:xfrm>
           <a:prstGeom prst="rect">
@@ -3854,7 +3788,7 @@
         </p:nvSpPr>
         <p:spPr>
           <a:xfrm>
-            <a:off x="2514600" y="3063240"/>
+            <a:off x="2514600" y="3282696"/>
             <a:ext cx="3246120" cy="548640"/>
           </a:xfrm>
           <a:prstGeom prst="rect">
@@ -3893,7 +3827,7 @@
         </p:nvSpPr>
         <p:spPr>
           <a:xfrm>
-            <a:off x="3954780" y="3621024"/>
+            <a:off x="3954780" y="3849624"/>
             <a:ext cx="365760" cy="256032"/>
           </a:xfrm>
           <a:prstGeom prst="rect">
@@ -3929,7 +3863,7 @@
         </p:nvSpPr>
         <p:spPr>
           <a:xfrm>
-            <a:off x="2514600" y="3794760"/>
+            <a:off x="2514600" y="4123944"/>
             <a:ext cx="3246120" cy="548640"/>
           </a:xfrm>
           <a:prstGeom prst="rect">
@@ -3961,7 +3895,7 @@
         </p:nvSpPr>
         <p:spPr>
           <a:xfrm>
-            <a:off x="2514600" y="3794760"/>
+            <a:off x="2514600" y="4123944"/>
             <a:ext cx="3246120" cy="548640"/>
           </a:xfrm>
           <a:prstGeom prst="rect">
@@ -4000,7 +3934,7 @@
         </p:nvSpPr>
         <p:spPr>
           <a:xfrm>
-            <a:off x="3954780" y="4352544"/>
+            <a:off x="3954780" y="4690872"/>
             <a:ext cx="365760" cy="256032"/>
           </a:xfrm>
           <a:prstGeom prst="rect">
@@ -4036,7 +3970,7 @@
         </p:nvSpPr>
         <p:spPr>
           <a:xfrm>
-            <a:off x="2514600" y="4526280"/>
+            <a:off x="2514600" y="4965192"/>
             <a:ext cx="3246120" cy="548640"/>
           </a:xfrm>
           <a:prstGeom prst="rect">
@@ -4068,7 +4002,7 @@
         </p:nvSpPr>
         <p:spPr>
           <a:xfrm>
-            <a:off x="2514600" y="4526280"/>
+            <a:off x="2514600" y="4965192"/>
             <a:ext cx="3246120" cy="548640"/>
           </a:xfrm>
           <a:prstGeom prst="rect">
@@ -4107,7 +4041,7 @@
         </p:nvSpPr>
         <p:spPr>
           <a:xfrm>
-            <a:off x="2194560" y="4800600"/>
+            <a:off x="2194560" y="5239512"/>
             <a:ext cx="320040" cy="0"/>
           </a:xfrm>
           <a:prstGeom prst="line">
@@ -4130,8 +4064,8 @@
         </p:nvSpPr>
         <p:spPr>
           <a:xfrm>
-            <a:off x="2194560" y="2606040"/>
-            <a:ext cx="0" cy="2194560"/>
+            <a:off x="2194560" y="2715768"/>
+            <a:ext cx="0" cy="2523744"/>
           </a:xfrm>
           <a:prstGeom prst="line">
             <a:avLst/>
@@ -4153,7 +4087,7 @@
         </p:nvSpPr>
         <p:spPr>
           <a:xfrm>
-            <a:off x="2194560" y="2606040"/>
+            <a:off x="2194560" y="2715768"/>
             <a:ext cx="320040" cy="0"/>
           </a:xfrm>
           <a:prstGeom prst="line">
@@ -4177,7 +4111,7 @@
         </p:nvSpPr>
         <p:spPr>
           <a:xfrm>
-            <a:off x="365760" y="3291840"/>
+            <a:off x="365760" y="3566160"/>
             <a:ext cx="1691640" cy="822960"/>
           </a:xfrm>
           <a:prstGeom prst="rect">
@@ -4241,7 +4175,7 @@
         </p:blipFill>
         <p:spPr>
           <a:xfrm>
-            <a:off x="2971800" y="4626864"/>
+            <a:off x="2971800" y="5065776"/>
             <a:ext cx="347472" cy="347472"/>
           </a:xfrm>
           <a:prstGeom prst="rect">
@@ -4760,6 +4694,9 @@
           <a:lstStyle/>
           <a:p>
             <a:pPr indent="0" marL="0">
+              <a:lnSpc>
+                <a:spcPct val="108000"/>
+              </a:lnSpc>
               <a:buNone/>
             </a:pPr>
             <a:r>
@@ -4824,6 +4761,9 @@
           <a:lstStyle/>
           <a:p>
             <a:pPr indent="0" marL="0">
+              <a:lnSpc>
+                <a:spcPct val="108000"/>
+              </a:lnSpc>
               <a:buNone/>
             </a:pPr>
             <a:r>
@@ -4838,6 +4778,9 @@
               <a:t>Goal:  </a:t>
             </a:r>
             <a:pPr indent="0" marL="0">
+              <a:lnSpc>
+                <a:spcPct val="108000"/>
+              </a:lnSpc>
               <a:buNone/>
             </a:pPr>
             <a:r>
@@ -5308,6 +5251,9 @@
           <a:lstStyle/>
           <a:p>
             <a:pPr indent="0" marL="0">
+              <a:lnSpc>
+                <a:spcPct val="112000"/>
+              </a:lnSpc>
               <a:buNone/>
             </a:pPr>
             <a:r>
@@ -5648,6 +5594,9 @@
           <a:lstStyle/>
           <a:p>
             <a:pPr indent="0" marL="0">
+              <a:lnSpc>
+                <a:spcPct val="112000"/>
+              </a:lnSpc>
               <a:buNone/>
             </a:pPr>
             <a:r>
@@ -5988,6 +5937,9 @@
           <a:lstStyle/>
           <a:p>
             <a:pPr indent="0" marL="0">
+              <a:lnSpc>
+                <a:spcPct val="112000"/>
+              </a:lnSpc>
               <a:buNone/>
             </a:pPr>
             <a:r>
@@ -6005,6 +5957,9 @@
           </a:p>
           <a:p>
             <a:pPr indent="0" marL="0">
+              <a:lnSpc>
+                <a:spcPct val="112000"/>
+              </a:lnSpc>
               <a:buNone/>
             </a:pPr>
             <a:r>
@@ -6022,6 +5977,9 @@
           </a:p>
           <a:p>
             <a:pPr indent="0" marL="0">
+              <a:lnSpc>
+                <a:spcPct val="112000"/>
+              </a:lnSpc>
               <a:buNone/>
             </a:pPr>
             <a:r>
@@ -6039,6 +5997,9 @@
           </a:p>
           <a:p>
             <a:pPr indent="0" marL="0">
+              <a:lnSpc>
+                <a:spcPct val="112000"/>
+              </a:lnSpc>
               <a:buNone/>
             </a:pPr>
             <a:r>
@@ -6379,6 +6340,9 @@
           <a:lstStyle/>
           <a:p>
             <a:pPr indent="0" marL="0">
+              <a:lnSpc>
+                <a:spcPct val="112000"/>
+              </a:lnSpc>
               <a:buNone/>
             </a:pPr>
             <a:r>
@@ -6396,6 +6360,9 @@
           </a:p>
           <a:p>
             <a:pPr indent="0" marL="0">
+              <a:lnSpc>
+                <a:spcPct val="112000"/>
+              </a:lnSpc>
               <a:buNone/>
             </a:pPr>
             <a:r>
@@ -6413,6 +6380,9 @@
           </a:p>
           <a:p>
             <a:pPr indent="0" marL="0">
+              <a:lnSpc>
+                <a:spcPct val="112000"/>
+              </a:lnSpc>
               <a:buNone/>
             </a:pPr>
             <a:r>
@@ -6427,6 +6397,9 @@
               <a:t>τ</a:t>
             </a:r>
             <a:pPr indent="0" marL="0">
+              <a:lnSpc>
+                <a:spcPct val="112000"/>
+              </a:lnSpc>
               <a:buNone/>
             </a:pPr>
             <a:r>
@@ -6441,6 +6414,9 @@
               <a:t>total</a:t>
             </a:r>
             <a:pPr indent="0" marL="0">
+              <a:lnSpc>
+                <a:spcPct val="112000"/>
+              </a:lnSpc>
               <a:buNone/>
             </a:pPr>
             <a:r>
@@ -6455,6 +6431,9 @@
               <a:t> = τ</a:t>
             </a:r>
             <a:pPr indent="0" marL="0">
+              <a:lnSpc>
+                <a:spcPct val="112000"/>
+              </a:lnSpc>
               <a:buNone/>
             </a:pPr>
             <a:r>
@@ -6469,6 +6448,9 @@
               <a:t>SATA</a:t>
             </a:r>
             <a:pPr indent="0" marL="0">
+              <a:lnSpc>
+                <a:spcPct val="112000"/>
+              </a:lnSpc>
               <a:buNone/>
             </a:pPr>
             <a:r>
@@ -6483,6 +6465,9 @@
               <a:t> + τ</a:t>
             </a:r>
             <a:pPr indent="0" marL="0">
+              <a:lnSpc>
+                <a:spcPct val="112000"/>
+              </a:lnSpc>
               <a:buNone/>
             </a:pPr>
             <a:r>
@@ -6500,6 +6485,9 @@
           </a:p>
           <a:p>
             <a:pPr indent="0" marL="0">
+              <a:lnSpc>
+                <a:spcPct val="112000"/>
+              </a:lnSpc>
               <a:buNone/>
             </a:pPr>
             <a:r>
@@ -6517,6 +6505,9 @@
           </a:p>
           <a:p>
             <a:pPr indent="0" marL="0">
+              <a:lnSpc>
+                <a:spcPct val="112000"/>
+              </a:lnSpc>
               <a:buNone/>
             </a:pPr>
             <a:r>
@@ -7573,6 +7564,9 @@
           <a:lstStyle/>
           <a:p>
             <a:pPr indent="0" marL="0">
+              <a:lnSpc>
+                <a:spcPct val="110000"/>
+              </a:lnSpc>
               <a:buNone/>
             </a:pPr>
             <a:r>
@@ -7703,6 +7697,9 @@
           <a:lstStyle/>
           <a:p>
             <a:pPr indent="0" marL="0">
+              <a:lnSpc>
+                <a:spcPct val="110000"/>
+              </a:lnSpc>
               <a:buNone/>
             </a:pPr>
             <a:r>
@@ -7833,6 +7830,9 @@
           <a:lstStyle/>
           <a:p>
             <a:pPr indent="0" marL="0">
+              <a:lnSpc>
+                <a:spcPct val="110000"/>
+              </a:lnSpc>
               <a:buNone/>
             </a:pPr>
             <a:r>
@@ -7963,6 +7963,9 @@
           <a:lstStyle/>
           <a:p>
             <a:pPr indent="0" marL="0">
+              <a:lnSpc>
+                <a:spcPct val="110000"/>
+              </a:lnSpc>
               <a:buNone/>
             </a:pPr>
             <a:r>

</xml_diff>

<commit_message>
Slide 1: sag the soft-terrain line under the dog's step
Replace the flat dashed soft-ground line with a shallow dipped dashed
line so the leg visibly sinks; nudge the right dog into the dip and keep
the caption clear.

https://claude.ai/code/session_015i3CJw2uiqwwXT61q7nN5g
</commit_message>
<xml_diff>
--- a/docs/progress-report-v1.pptx
+++ b/docs/progress-report-v1.pptx
@@ -2121,11 +2121,11 @@
         <p:spPr>
           <a:xfrm>
             <a:off x="502920" y="2788920"/>
-            <a:ext cx="4983480" cy="1188720"/>
+            <a:ext cx="4983480" cy="1243584"/>
           </a:xfrm>
           <a:prstGeom prst="roundRect">
             <a:avLst>
-              <a:gd name="adj" fmla="val 4615"/>
+              <a:gd name="adj" fmla="val 4412"/>
             </a:avLst>
           </a:prstGeom>
           <a:solidFill>
@@ -2210,7 +2210,7 @@
         </p:nvSpPr>
         <p:spPr>
           <a:xfrm>
-            <a:off x="731520" y="3703320"/>
+            <a:off x="731520" y="3694176"/>
             <a:ext cx="1417320" cy="0"/>
           </a:xfrm>
           <a:prstGeom prst="line">
@@ -2233,8 +2233,8 @@
         </p:nvSpPr>
         <p:spPr>
           <a:xfrm>
-            <a:off x="640080" y="3739896"/>
-            <a:ext cx="1600200" cy="219456"/>
+            <a:off x="640080" y="3822192"/>
+            <a:ext cx="1600200" cy="201168"/>
           </a:xfrm>
           <a:prstGeom prst="rect">
             <a:avLst/>
@@ -2304,7 +2304,7 @@
         </p:blipFill>
         <p:spPr>
           <a:xfrm>
-            <a:off x="3611880" y="3163824"/>
+            <a:off x="3611880" y="3236976"/>
             <a:ext cx="512064" cy="512064"/>
           </a:xfrm>
           <a:prstGeom prst="rect">
@@ -2328,7 +2328,7 @@
         </p:blipFill>
         <p:spPr>
           <a:xfrm>
-            <a:off x="4242816" y="2999232"/>
+            <a:off x="4242816" y="3035808"/>
             <a:ext cx="256032" cy="365760"/>
           </a:xfrm>
           <a:prstGeom prst="rect">
@@ -2352,7 +2352,7 @@
         </p:blipFill>
         <p:spPr>
           <a:xfrm>
-            <a:off x="5047488" y="3182112"/>
+            <a:off x="5047488" y="3200400"/>
             <a:ext cx="219456" cy="219456"/>
           </a:xfrm>
           <a:prstGeom prst="rect">
@@ -2368,8 +2368,8 @@
         </p:nvSpPr>
         <p:spPr>
           <a:xfrm>
-            <a:off x="3154680" y="3703320"/>
-            <a:ext cx="2057400" cy="0"/>
+            <a:off x="3154680" y="3694176"/>
+            <a:ext cx="685800" cy="82296"/>
           </a:xfrm>
           <a:prstGeom prst="line">
             <a:avLst/>
@@ -2385,14 +2385,60 @@
       </p:sp>
       <p:sp>
         <p:nvSpPr>
-          <p:cNvPr id="20" name="Text 13"/>
-          <p:cNvSpPr/>
-          <p:nvPr/>
-        </p:nvSpPr>
-        <p:spPr>
-          <a:xfrm>
-            <a:off x="3246120" y="3739896"/>
-            <a:ext cx="1874520" cy="219456"/>
+          <p:cNvPr id="20" name="Shape 13"/>
+          <p:cNvSpPr/>
+          <p:nvPr/>
+        </p:nvSpPr>
+        <p:spPr>
+          <a:xfrm>
+            <a:off x="3840480" y="3776472"/>
+            <a:ext cx="530352" cy="0"/>
+          </a:xfrm>
+          <a:prstGeom prst="line">
+            <a:avLst/>
+          </a:prstGeom>
+          <a:noFill/>
+          <a:ln w="38100">
+            <a:solidFill>
+              <a:srgbClr val="B0573F"/>
+            </a:solidFill>
+            <a:prstDash val="dash"/>
+          </a:ln>
+        </p:spPr>
+      </p:sp>
+      <p:sp>
+        <p:nvSpPr>
+          <p:cNvPr id="21" name="Shape 14"/>
+          <p:cNvSpPr/>
+          <p:nvPr/>
+        </p:nvSpPr>
+        <p:spPr>
+          <a:xfrm>
+            <a:off x="4370832" y="3776472"/>
+            <a:ext cx="841248" cy="-82296"/>
+          </a:xfrm>
+          <a:prstGeom prst="line">
+            <a:avLst/>
+          </a:prstGeom>
+          <a:noFill/>
+          <a:ln w="38100">
+            <a:solidFill>
+              <a:srgbClr val="B0573F"/>
+            </a:solidFill>
+            <a:prstDash val="dash"/>
+          </a:ln>
+        </p:spPr>
+      </p:sp>
+      <p:sp>
+        <p:nvSpPr>
+          <p:cNvPr id="22" name="Text 15"/>
+          <p:cNvSpPr/>
+          <p:nvPr/>
+        </p:nvSpPr>
+        <p:spPr>
+          <a:xfrm>
+            <a:off x="3246120" y="3822192"/>
+            <a:ext cx="1874520" cy="201168"/>
           </a:xfrm>
           <a:prstGeom prst="rect">
             <a:avLst/>
@@ -2424,7 +2470,7 @@
       </p:sp>
       <p:sp>
         <p:nvSpPr>
-          <p:cNvPr id="21" name="Shape 14"/>
+          <p:cNvPr id="23" name="Shape 16"/>
           <p:cNvSpPr/>
           <p:nvPr/>
         </p:nvSpPr>
@@ -2444,7 +2490,7 @@
       </p:sp>
       <p:sp>
         <p:nvSpPr>
-          <p:cNvPr id="22" name="Text 15"/>
+          <p:cNvPr id="24" name="Text 17"/>
           <p:cNvSpPr/>
           <p:nvPr/>
         </p:nvSpPr>
@@ -2483,7 +2529,7 @@
       </p:sp>
       <p:sp>
         <p:nvSpPr>
-          <p:cNvPr id="23" name="Shape 16"/>
+          <p:cNvPr id="25" name="Shape 18"/>
           <p:cNvSpPr/>
           <p:nvPr/>
         </p:nvSpPr>
@@ -2503,7 +2549,7 @@
       </p:sp>
       <p:sp>
         <p:nvSpPr>
-          <p:cNvPr id="24" name="Text 17"/>
+          <p:cNvPr id="26" name="Text 19"/>
           <p:cNvSpPr/>
           <p:nvPr/>
         </p:nvSpPr>
@@ -2542,7 +2588,7 @@
       </p:sp>
       <p:sp>
         <p:nvSpPr>
-          <p:cNvPr id="25" name="Shape 18"/>
+          <p:cNvPr id="27" name="Shape 20"/>
           <p:cNvSpPr/>
           <p:nvPr/>
         </p:nvSpPr>
@@ -2562,7 +2608,7 @@
       </p:sp>
       <p:sp>
         <p:nvSpPr>
-          <p:cNvPr id="26" name="Text 19"/>
+          <p:cNvPr id="28" name="Text 21"/>
           <p:cNvSpPr/>
           <p:nvPr/>
         </p:nvSpPr>
@@ -2601,7 +2647,7 @@
       </p:sp>
       <p:sp>
         <p:nvSpPr>
-          <p:cNvPr id="27" name="Shape 20"/>
+          <p:cNvPr id="29" name="Shape 22"/>
           <p:cNvSpPr/>
           <p:nvPr/>
         </p:nvSpPr>
@@ -2626,7 +2672,7 @@
       </p:sp>
       <p:sp>
         <p:nvSpPr>
-          <p:cNvPr id="28" name="Text 21"/>
+          <p:cNvPr id="30" name="Text 23"/>
           <p:cNvSpPr/>
           <p:nvPr/>
         </p:nvSpPr>
@@ -2665,7 +2711,7 @@
       </p:sp>
       <p:sp>
         <p:nvSpPr>
-          <p:cNvPr id="29" name="Shape 22"/>
+          <p:cNvPr id="31" name="Shape 24"/>
           <p:cNvSpPr/>
           <p:nvPr/>
         </p:nvSpPr>
@@ -2690,7 +2736,7 @@
       </p:sp>
       <p:sp>
         <p:nvSpPr>
-          <p:cNvPr id="30" name="Text 23"/>
+          <p:cNvPr id="32" name="Text 25"/>
           <p:cNvSpPr/>
           <p:nvPr/>
         </p:nvSpPr>
@@ -2729,7 +2775,7 @@
       </p:sp>
       <p:sp>
         <p:nvSpPr>
-          <p:cNvPr id="31" name="Text 24"/>
+          <p:cNvPr id="33" name="Text 26"/>
           <p:cNvSpPr/>
           <p:nvPr/>
         </p:nvSpPr>
@@ -2765,7 +2811,7 @@
       </p:sp>
       <p:sp>
         <p:nvSpPr>
-          <p:cNvPr id="32" name="Text 25"/>
+          <p:cNvPr id="34" name="Text 27"/>
           <p:cNvSpPr/>
           <p:nvPr/>
         </p:nvSpPr>
@@ -2801,7 +2847,7 @@
       </p:sp>
       <p:sp>
         <p:nvSpPr>
-          <p:cNvPr id="33" name="Shape 26"/>
+          <p:cNvPr id="35" name="Shape 28"/>
           <p:cNvSpPr/>
           <p:nvPr/>
         </p:nvSpPr>
@@ -2826,7 +2872,7 @@
       </p:sp>
       <p:sp>
         <p:nvSpPr>
-          <p:cNvPr id="34" name="Text 27"/>
+          <p:cNvPr id="36" name="Text 29"/>
           <p:cNvSpPr/>
           <p:nvPr/>
         </p:nvSpPr>
@@ -2865,7 +2911,7 @@
       </p:sp>
       <p:sp>
         <p:nvSpPr>
-          <p:cNvPr id="35" name="Shape 28"/>
+          <p:cNvPr id="37" name="Shape 30"/>
           <p:cNvSpPr/>
           <p:nvPr/>
         </p:nvSpPr>
@@ -2890,7 +2936,7 @@
       </p:sp>
       <p:sp>
         <p:nvSpPr>
-          <p:cNvPr id="36" name="Text 29"/>
+          <p:cNvPr id="38" name="Text 31"/>
           <p:cNvSpPr/>
           <p:nvPr/>
         </p:nvSpPr>
@@ -2929,7 +2975,7 @@
       </p:sp>
       <p:sp>
         <p:nvSpPr>
-          <p:cNvPr id="37" name="Text 30"/>
+          <p:cNvPr id="39" name="Text 32"/>
           <p:cNvSpPr/>
           <p:nvPr/>
         </p:nvSpPr>
@@ -2965,7 +3011,7 @@
       </p:sp>
       <p:sp>
         <p:nvSpPr>
-          <p:cNvPr id="38" name="Text 31"/>
+          <p:cNvPr id="40" name="Text 33"/>
           <p:cNvSpPr/>
           <p:nvPr/>
         </p:nvSpPr>
@@ -3001,7 +3047,7 @@
       </p:sp>
       <p:sp>
         <p:nvSpPr>
-          <p:cNvPr id="39" name="Shape 32"/>
+          <p:cNvPr id="41" name="Shape 34"/>
           <p:cNvSpPr/>
           <p:nvPr/>
         </p:nvSpPr>
@@ -3026,7 +3072,7 @@
       </p:sp>
       <p:sp>
         <p:nvSpPr>
-          <p:cNvPr id="40" name="Text 33"/>
+          <p:cNvPr id="42" name="Text 35"/>
           <p:cNvSpPr/>
           <p:nvPr/>
         </p:nvSpPr>
@@ -3065,7 +3111,7 @@
       </p:sp>
       <p:sp>
         <p:nvSpPr>
-          <p:cNvPr id="41" name="Shape 34"/>
+          <p:cNvPr id="43" name="Shape 36"/>
           <p:cNvSpPr/>
           <p:nvPr/>
         </p:nvSpPr>
@@ -3090,7 +3136,7 @@
       </p:sp>
       <p:sp>
         <p:nvSpPr>
-          <p:cNvPr id="42" name="Text 35"/>
+          <p:cNvPr id="44" name="Text 37"/>
           <p:cNvSpPr/>
           <p:nvPr/>
         </p:nvSpPr>
@@ -3129,7 +3175,7 @@
       </p:sp>
       <p:sp>
         <p:nvSpPr>
-          <p:cNvPr id="43" name="Shape 36"/>
+          <p:cNvPr id="45" name="Shape 38"/>
           <p:cNvSpPr/>
           <p:nvPr/>
         </p:nvSpPr>
@@ -3149,7 +3195,7 @@
       </p:sp>
       <p:sp>
         <p:nvSpPr>
-          <p:cNvPr id="44" name="Text 37"/>
+          <p:cNvPr id="46" name="Text 39"/>
           <p:cNvSpPr/>
           <p:nvPr/>
         </p:nvSpPr>
@@ -3188,7 +3234,7 @@
       </p:sp>
       <p:sp>
         <p:nvSpPr>
-          <p:cNvPr id="45" name="Text 38"/>
+          <p:cNvPr id="47" name="Text 40"/>
           <p:cNvSpPr/>
           <p:nvPr/>
         </p:nvSpPr>
@@ -3227,7 +3273,7 @@
       </p:sp>
       <p:sp>
         <p:nvSpPr>
-          <p:cNvPr id="46" name="Text 39"/>
+          <p:cNvPr id="48" name="Text 41"/>
           <p:cNvSpPr/>
           <p:nvPr/>
         </p:nvSpPr>
@@ -3294,7 +3340,7 @@
       </p:sp>
       <p:sp>
         <p:nvSpPr>
-          <p:cNvPr id="47" name="Text 40"/>
+          <p:cNvPr id="49" name="Text 42"/>
           <p:cNvSpPr/>
           <p:nvPr/>
         </p:nvSpPr>

</xml_diff>